<commit_message>
update: modify 高级Web实验及实验报告 document and remove icon-bs-master.zip and workspace.xml files
</commit_message>
<xml_diff>
--- a/课件/part3.JSP:Servlet:SSM/第16章 课程总结.pptx
+++ b/课件/part3.JSP:Servlet:SSM/第16章 课程总结.pptx
@@ -5,22 +5,22 @@
     <p:sldMasterId id="2147483648" r:id="rId1"/>
   </p:sldMasterIdLst>
   <p:notesMasterIdLst>
-    <p:notesMasterId r:id="rId5"/>
+    <p:notesMasterId r:id="rId15"/>
   </p:notesMasterIdLst>
   <p:sldIdLst>
-    <p:sldId id="267" r:id="rId3"/>
-    <p:sldId id="257" r:id="rId4"/>
-    <p:sldId id="269" r:id="rId6"/>
-    <p:sldId id="270" r:id="rId7"/>
-    <p:sldId id="256" r:id="rId8"/>
-    <p:sldId id="258" r:id="rId9"/>
-    <p:sldId id="260" r:id="rId10"/>
-    <p:sldId id="261" r:id="rId11"/>
-    <p:sldId id="262" r:id="rId12"/>
-    <p:sldId id="263" r:id="rId13"/>
-    <p:sldId id="264" r:id="rId14"/>
-    <p:sldId id="268" r:id="rId15"/>
-    <p:sldId id="265" r:id="rId16"/>
+    <p:sldId id="267" r:id="rId2"/>
+    <p:sldId id="257" r:id="rId3"/>
+    <p:sldId id="269" r:id="rId4"/>
+    <p:sldId id="270" r:id="rId5"/>
+    <p:sldId id="256" r:id="rId6"/>
+    <p:sldId id="258" r:id="rId7"/>
+    <p:sldId id="260" r:id="rId8"/>
+    <p:sldId id="261" r:id="rId9"/>
+    <p:sldId id="262" r:id="rId10"/>
+    <p:sldId id="263" r:id="rId11"/>
+    <p:sldId id="264" r:id="rId12"/>
+    <p:sldId id="268" r:id="rId13"/>
+    <p:sldId id="265" r:id="rId14"/>
   </p:sldIdLst>
   <p:sldSz cx="9144000" cy="6858000" type="screen4x3"/>
   <p:notesSz cx="6858000" cy="9144000"/>
@@ -139,7 +139,7 @@
 </file>
 
 <file path=ppt/diagrams/colors1.xml><?xml version="1.0" encoding="utf-8"?>
-<dgm:colorsDef xmlns:dgm="http://schemas.openxmlformats.org/drawingml/2006/diagram" xmlns:a="http://schemas.openxmlformats.org/drawingml/2006/main" uniqueId="urn:microsoft.com/office/officeart/2005/8/colors/accent0_3">
+<dgm:colorsDef xmlns:dgm="http://schemas.openxmlformats.org/drawingml/2006/diagram" xmlns:a="http://schemas.openxmlformats.org/drawingml/2006/main" uniqueId="urn:microsoft.com/office/officeart/2005/8/colors/accent0_3#1">
   <dgm:title val=""/>
   <dgm:desc val=""/>
   <dgm:catLst>
@@ -1814,7 +1814,7 @@
 <dgm:dataModel xmlns:dgm="http://schemas.openxmlformats.org/drawingml/2006/diagram" xmlns:a="http://schemas.openxmlformats.org/drawingml/2006/main">
   <dgm:ptLst>
     <dgm:pt modelId="{8915C626-BB86-45EC-9590-6C5F764E6482}" type="doc">
-      <dgm:prSet loTypeId="urn:microsoft.com/office/officeart/2005/8/layout/hList1" loCatId="list" qsTypeId="urn:microsoft.com/office/officeart/2005/8/quickstyle/simple1" qsCatId="simple" csTypeId="urn:microsoft.com/office/officeart/2005/8/colors/accent0_3" csCatId="mainScheme"/>
+      <dgm:prSet loTypeId="urn:microsoft.com/office/officeart/2005/8/layout/hList1" loCatId="list" qsTypeId="urn:microsoft.com/office/officeart/2005/8/quickstyle/simple1#1" qsCatId="simple" csTypeId="urn:microsoft.com/office/officeart/2005/8/colors/accent0_3#1" csCatId="mainScheme"/>
       <dgm:spPr/>
       <dgm:t>
         <a:bodyPr/>
@@ -1838,7 +1838,7 @@
         </a:p>
       </dgm:t>
     </dgm:pt>
-    <dgm:pt modelId="{F49F266B-FC10-4309-9168-B7E22F2D4FCB}" cxnId="{C854E6E9-404D-418B-855A-8DF6E00C6188}" type="parTrans">
+    <dgm:pt modelId="{F49F266B-FC10-4309-9168-B7E22F2D4FCB}" type="parTrans" cxnId="{C854E6E9-404D-418B-855A-8DF6E00C6188}">
       <dgm:prSet/>
       <dgm:spPr/>
       <dgm:t>
@@ -1849,7 +1849,7 @@
         </a:p>
       </dgm:t>
     </dgm:pt>
-    <dgm:pt modelId="{19A2ACAB-4522-4B4C-A83A-714E148F273F}" cxnId="{C854E6E9-404D-418B-855A-8DF6E00C6188}" type="sibTrans">
+    <dgm:pt modelId="{19A2ACAB-4522-4B4C-A83A-714E148F273F}" type="sibTrans" cxnId="{C854E6E9-404D-418B-855A-8DF6E00C6188}">
       <dgm:prSet/>
       <dgm:spPr/>
       <dgm:t>
@@ -1874,7 +1874,7 @@
         </a:p>
       </dgm:t>
     </dgm:pt>
-    <dgm:pt modelId="{74D0D657-E9F8-463F-BE4D-871EC917C8E6}" cxnId="{E781D3D4-3AE9-4660-AC24-C84C8E901202}" type="parTrans">
+    <dgm:pt modelId="{74D0D657-E9F8-463F-BE4D-871EC917C8E6}" type="parTrans" cxnId="{E781D3D4-3AE9-4660-AC24-C84C8E901202}">
       <dgm:prSet/>
       <dgm:spPr/>
       <dgm:t>
@@ -1885,7 +1885,7 @@
         </a:p>
       </dgm:t>
     </dgm:pt>
-    <dgm:pt modelId="{9A447117-E763-43FD-A291-E8C0568A8C25}" cxnId="{E781D3D4-3AE9-4660-AC24-C84C8E901202}" type="sibTrans">
+    <dgm:pt modelId="{9A447117-E763-43FD-A291-E8C0568A8C25}" type="sibTrans" cxnId="{E781D3D4-3AE9-4660-AC24-C84C8E901202}">
       <dgm:prSet/>
       <dgm:spPr/>
       <dgm:t>
@@ -1910,7 +1910,7 @@
         </a:p>
       </dgm:t>
     </dgm:pt>
-    <dgm:pt modelId="{205B6326-9354-41FB-8395-52AECB18827F}" cxnId="{11A1AC65-99A9-455A-90D7-CC36D462043B}" type="parTrans">
+    <dgm:pt modelId="{205B6326-9354-41FB-8395-52AECB18827F}" type="parTrans" cxnId="{11A1AC65-99A9-455A-90D7-CC36D462043B}">
       <dgm:prSet/>
       <dgm:spPr/>
       <dgm:t>
@@ -1921,7 +1921,7 @@
         </a:p>
       </dgm:t>
     </dgm:pt>
-    <dgm:pt modelId="{E51CF588-66FF-4E34-8579-12224D028466}" cxnId="{11A1AC65-99A9-455A-90D7-CC36D462043B}" type="sibTrans">
+    <dgm:pt modelId="{E51CF588-66FF-4E34-8579-12224D028466}" type="sibTrans" cxnId="{11A1AC65-99A9-455A-90D7-CC36D462043B}">
       <dgm:prSet/>
       <dgm:spPr/>
       <dgm:t>
@@ -1946,7 +1946,7 @@
         </a:p>
       </dgm:t>
     </dgm:pt>
-    <dgm:pt modelId="{59E5557A-E586-4DA7-B618-A7F12D8994C4}" cxnId="{EA931F86-AC39-4467-9997-5E0E38695E63}" type="parTrans">
+    <dgm:pt modelId="{59E5557A-E586-4DA7-B618-A7F12D8994C4}" type="parTrans" cxnId="{EA931F86-AC39-4467-9997-5E0E38695E63}">
       <dgm:prSet/>
       <dgm:spPr/>
       <dgm:t>
@@ -1957,7 +1957,7 @@
         </a:p>
       </dgm:t>
     </dgm:pt>
-    <dgm:pt modelId="{8A680D40-FCD4-4B88-B895-837176441150}" cxnId="{EA931F86-AC39-4467-9997-5E0E38695E63}" type="sibTrans">
+    <dgm:pt modelId="{8A680D40-FCD4-4B88-B895-837176441150}" type="sibTrans" cxnId="{EA931F86-AC39-4467-9997-5E0E38695E63}">
       <dgm:prSet/>
       <dgm:spPr/>
       <dgm:t>
@@ -1982,7 +1982,7 @@
         </a:p>
       </dgm:t>
     </dgm:pt>
-    <dgm:pt modelId="{731CDFC0-7827-41D7-AECA-546451532A9D}" cxnId="{5B5B1C63-B18A-4566-9F29-52BDFDB7AE22}" type="parTrans">
+    <dgm:pt modelId="{731CDFC0-7827-41D7-AECA-546451532A9D}" type="parTrans" cxnId="{5B5B1C63-B18A-4566-9F29-52BDFDB7AE22}">
       <dgm:prSet/>
       <dgm:spPr/>
       <dgm:t>
@@ -1993,7 +1993,7 @@
         </a:p>
       </dgm:t>
     </dgm:pt>
-    <dgm:pt modelId="{4ED15F46-65FF-434E-A4DD-D31CE2097C6F}" cxnId="{5B5B1C63-B18A-4566-9F29-52BDFDB7AE22}" type="sibTrans">
+    <dgm:pt modelId="{4ED15F46-65FF-434E-A4DD-D31CE2097C6F}" type="sibTrans" cxnId="{5B5B1C63-B18A-4566-9F29-52BDFDB7AE22}">
       <dgm:prSet/>
       <dgm:spPr/>
       <dgm:t>
@@ -2023,7 +2023,7 @@
         </a:p>
       </dgm:t>
     </dgm:pt>
-    <dgm:pt modelId="{055E5D03-E4FB-47C2-9B3B-A87175000DD4}" cxnId="{1354DBD4-B61B-409C-9A7D-242BC4108166}" type="parTrans">
+    <dgm:pt modelId="{055E5D03-E4FB-47C2-9B3B-A87175000DD4}" type="parTrans" cxnId="{1354DBD4-B61B-409C-9A7D-242BC4108166}">
       <dgm:prSet/>
       <dgm:spPr/>
       <dgm:t>
@@ -2034,7 +2034,7 @@
         </a:p>
       </dgm:t>
     </dgm:pt>
-    <dgm:pt modelId="{9ED078B0-F237-4CF4-87E6-8DFC32A19546}" cxnId="{1354DBD4-B61B-409C-9A7D-242BC4108166}" type="sibTrans">
+    <dgm:pt modelId="{9ED078B0-F237-4CF4-87E6-8DFC32A19546}" type="sibTrans" cxnId="{1354DBD4-B61B-409C-9A7D-242BC4108166}">
       <dgm:prSet/>
       <dgm:spPr/>
       <dgm:t>
@@ -2059,7 +2059,7 @@
         </a:p>
       </dgm:t>
     </dgm:pt>
-    <dgm:pt modelId="{4E8F41E5-60FB-45B2-AC04-3DB8DB379F10}" cxnId="{DC13A048-8A20-4EE0-BF2E-760142D85966}" type="parTrans">
+    <dgm:pt modelId="{4E8F41E5-60FB-45B2-AC04-3DB8DB379F10}" type="parTrans" cxnId="{DC13A048-8A20-4EE0-BF2E-760142D85966}">
       <dgm:prSet/>
       <dgm:spPr/>
       <dgm:t>
@@ -2070,7 +2070,7 @@
         </a:p>
       </dgm:t>
     </dgm:pt>
-    <dgm:pt modelId="{78F75815-3BD7-44D0-8A37-1A2EFAB0AAAA}" cxnId="{DC13A048-8A20-4EE0-BF2E-760142D85966}" type="sibTrans">
+    <dgm:pt modelId="{78F75815-3BD7-44D0-8A37-1A2EFAB0AAAA}" type="sibTrans" cxnId="{DC13A048-8A20-4EE0-BF2E-760142D85966}">
       <dgm:prSet/>
       <dgm:spPr/>
       <dgm:t>
@@ -2100,7 +2100,7 @@
         </a:p>
       </dgm:t>
     </dgm:pt>
-    <dgm:pt modelId="{AAA7C242-8361-496A-B410-077149D4B36B}" cxnId="{7680888B-D3CD-4804-9946-F41A31246FDD}" type="parTrans">
+    <dgm:pt modelId="{AAA7C242-8361-496A-B410-077149D4B36B}" type="parTrans" cxnId="{7680888B-D3CD-4804-9946-F41A31246FDD}">
       <dgm:prSet/>
       <dgm:spPr/>
       <dgm:t>
@@ -2111,7 +2111,7 @@
         </a:p>
       </dgm:t>
     </dgm:pt>
-    <dgm:pt modelId="{DDAA8669-B0A7-4B6D-A225-1E8231033C94}" cxnId="{7680888B-D3CD-4804-9946-F41A31246FDD}" type="sibTrans">
+    <dgm:pt modelId="{DDAA8669-B0A7-4B6D-A225-1E8231033C94}" type="sibTrans" cxnId="{7680888B-D3CD-4804-9946-F41A31246FDD}">
       <dgm:prSet/>
       <dgm:spPr/>
       <dgm:t>
@@ -2271,7 +2271,7 @@
   <dgm:whole/>
   <dgm:extLst>
     <a:ext uri="http://schemas.microsoft.com/office/drawing/2008/diagram">
-      <dsp:dataModelExt xmlns:dsp="http://schemas.microsoft.com/office/drawing/2008/diagram" relId="rId6" minVer="http://schemas.openxmlformats.org/drawingml/2006/diagram"/>
+      <dsp:dataModelExt xmlns:dsp="http://schemas.microsoft.com/office/drawing/2008/diagram" relId="rId8" minVer="http://schemas.openxmlformats.org/drawingml/2006/diagram"/>
     </a:ext>
   </dgm:extLst>
 </dgm:dataModel>
@@ -2281,7 +2281,7 @@
 <dgm:dataModel xmlns:dgm="http://schemas.openxmlformats.org/drawingml/2006/diagram" xmlns:a="http://schemas.openxmlformats.org/drawingml/2006/main">
   <dgm:ptLst>
     <dgm:pt modelId="{7979ABE6-EA1B-4426-B8D6-AEDA77E55FC3}" type="doc">
-      <dgm:prSet loTypeId="urn:microsoft.com/office/officeart/2018/5/layout/CenteredIconLabelDescriptionList" loCatId="icon" qsTypeId="urn:microsoft.com/office/officeart/2005/8/quickstyle/simple1" qsCatId="simple" csTypeId="urn:microsoft.com/office/officeart/2018/5/colors/Iconchunking_neutralbg_colorful1" csCatId="colorful" phldr="1"/>
+      <dgm:prSet loTypeId="urn:microsoft.com/office/officeart/2018/5/layout/CenteredIconLabelDescriptionList" loCatId="icon" qsTypeId="urn:microsoft.com/office/officeart/2005/8/quickstyle/simple1#2" qsCatId="simple" csTypeId="urn:microsoft.com/office/officeart/2018/5/colors/Iconchunking_neutralbg_colorful1" csCatId="colorful" phldr="1"/>
       <dgm:spPr/>
       <dgm:t>
         <a:bodyPr/>
@@ -2323,7 +2323,7 @@
         </a:p>
       </dgm:t>
     </dgm:pt>
-    <dgm:pt modelId="{BBD45F0E-FA3C-4241-88EE-1DC1C04917D1}" cxnId="{895DCC88-2102-4605-8ED6-8445142CDA2C}" type="parTrans">
+    <dgm:pt modelId="{BBD45F0E-FA3C-4241-88EE-1DC1C04917D1}" type="parTrans" cxnId="{895DCC88-2102-4605-8ED6-8445142CDA2C}">
       <dgm:prSet/>
       <dgm:spPr/>
       <dgm:t>
@@ -2334,7 +2334,7 @@
         </a:p>
       </dgm:t>
     </dgm:pt>
-    <dgm:pt modelId="{5FEA99A5-8CA1-4D7A-8D67-CDA40291055C}" cxnId="{895DCC88-2102-4605-8ED6-8445142CDA2C}" type="sibTrans">
+    <dgm:pt modelId="{5FEA99A5-8CA1-4D7A-8D67-CDA40291055C}" type="sibTrans" cxnId="{895DCC88-2102-4605-8ED6-8445142CDA2C}">
       <dgm:prSet/>
       <dgm:spPr/>
       <dgm:t>
@@ -2367,7 +2367,7 @@
         </a:p>
       </dgm:t>
     </dgm:pt>
-    <dgm:pt modelId="{9DD0152F-03E7-4877-8973-E62CD6FEBA8B}" cxnId="{EA609C2A-65B5-4FCF-B999-AE9BC9C365AE}" type="parTrans">
+    <dgm:pt modelId="{9DD0152F-03E7-4877-8973-E62CD6FEBA8B}" type="parTrans" cxnId="{EA609C2A-65B5-4FCF-B999-AE9BC9C365AE}">
       <dgm:prSet/>
       <dgm:spPr/>
       <dgm:t>
@@ -2378,7 +2378,7 @@
         </a:p>
       </dgm:t>
     </dgm:pt>
-    <dgm:pt modelId="{6F83C7F6-4E74-4EFD-A750-BE0A110B9FA3}" cxnId="{EA609C2A-65B5-4FCF-B999-AE9BC9C365AE}" type="sibTrans">
+    <dgm:pt modelId="{6F83C7F6-4E74-4EFD-A750-BE0A110B9FA3}" type="sibTrans" cxnId="{EA609C2A-65B5-4FCF-B999-AE9BC9C365AE}">
       <dgm:prSet/>
       <dgm:spPr/>
       <dgm:t>
@@ -2421,7 +2421,7 @@
         </a:p>
       </dgm:t>
     </dgm:pt>
-    <dgm:pt modelId="{876B4A50-C4A4-4CEF-BE2C-640295E1B0B0}" cxnId="{4F346D22-2281-42D9-9F8D-AA8FA3ED6079}" type="parTrans">
+    <dgm:pt modelId="{876B4A50-C4A4-4CEF-BE2C-640295E1B0B0}" type="parTrans" cxnId="{4F346D22-2281-42D9-9F8D-AA8FA3ED6079}">
       <dgm:prSet/>
       <dgm:spPr/>
       <dgm:t>
@@ -2432,7 +2432,7 @@
         </a:p>
       </dgm:t>
     </dgm:pt>
-    <dgm:pt modelId="{68ED2CCD-2ABA-4727-9535-96A958E63768}" cxnId="{4F346D22-2281-42D9-9F8D-AA8FA3ED6079}" type="sibTrans">
+    <dgm:pt modelId="{68ED2CCD-2ABA-4727-9535-96A958E63768}" type="sibTrans" cxnId="{4F346D22-2281-42D9-9F8D-AA8FA3ED6079}">
       <dgm:prSet/>
       <dgm:spPr/>
       <dgm:t>
@@ -2491,7 +2491,7 @@
         </a:p>
       </dgm:t>
     </dgm:pt>
-    <dgm:pt modelId="{5F5EE719-9B96-42DC-93AA-05A73F55305C}" cxnId="{EBB2A255-C7EC-4F98-8D1B-6391A509DE2A}" type="parTrans">
+    <dgm:pt modelId="{5F5EE719-9B96-42DC-93AA-05A73F55305C}" type="parTrans" cxnId="{EBB2A255-C7EC-4F98-8D1B-6391A509DE2A}">
       <dgm:prSet/>
       <dgm:spPr/>
       <dgm:t>
@@ -2502,7 +2502,7 @@
         </a:p>
       </dgm:t>
     </dgm:pt>
-    <dgm:pt modelId="{B1378C86-3A45-4DD0-B442-6CF0D1A6FBCB}" cxnId="{EBB2A255-C7EC-4F98-8D1B-6391A509DE2A}" type="sibTrans">
+    <dgm:pt modelId="{B1378C86-3A45-4DD0-B442-6CF0D1A6FBCB}" type="sibTrans" cxnId="{EBB2A255-C7EC-4F98-8D1B-6391A509DE2A}">
       <dgm:prSet/>
       <dgm:spPr/>
       <dgm:t>
@@ -2530,13 +2530,13 @@
       <dgm:prSet presAssocID="{4B6F06D1-F545-4E3F-AC90-49B955228BEC}" presName="iconRect" presStyleLbl="node1" presStyleIdx="0" presStyleCnt="3"/>
       <dgm:spPr>
         <a:blipFill>
-          <a:blip xmlns:r="http://schemas.openxmlformats.org/officeDocument/2006/relationships" r:embed="rId2">
+          <a:blip xmlns:r="http://schemas.openxmlformats.org/officeDocument/2006/relationships">
             <a:extLst>
               <a:ext uri="{28A0092B-C50C-407E-A947-70E740481C1C}">
                 <a14:useLocalDpi xmlns:a14="http://schemas.microsoft.com/office/drawing/2010/main" val="0"/>
               </a:ext>
               <a:ext uri="{96DAC541-7B7A-43D3-8B79-37D633B846F1}">
-                <asvg:svgBlip xmlns:asvg="http://schemas.microsoft.com/office/drawing/2016/SVG/main" r:embed="rId3"/>
+                <asvg:svgBlip xmlns:asvg="http://schemas.microsoft.com/office/drawing/2016/SVG/main" r:embed="rId2"/>
               </a:ext>
             </a:extLst>
           </a:blip>
@@ -2584,13 +2584,13 @@
       <dgm:prSet presAssocID="{A5477C72-68A3-4CFF-81D9-87B1AD307127}" presName="iconRect" presStyleLbl="node1" presStyleIdx="1" presStyleCnt="3"/>
       <dgm:spPr>
         <a:blipFill>
-          <a:blip xmlns:r="http://schemas.openxmlformats.org/officeDocument/2006/relationships" r:embed="rId4">
+          <a:blip xmlns:r="http://schemas.openxmlformats.org/officeDocument/2006/relationships">
             <a:extLst>
               <a:ext uri="{28A0092B-C50C-407E-A947-70E740481C1C}">
                 <a14:useLocalDpi xmlns:a14="http://schemas.microsoft.com/office/drawing/2010/main" val="0"/>
               </a:ext>
               <a:ext uri="{96DAC541-7B7A-43D3-8B79-37D633B846F1}">
-                <asvg:svgBlip xmlns:asvg="http://schemas.microsoft.com/office/drawing/2016/SVG/main" r:embed="rId5"/>
+                <asvg:svgBlip xmlns:asvg="http://schemas.microsoft.com/office/drawing/2016/SVG/main" r:embed="rId3"/>
               </a:ext>
             </a:extLst>
           </a:blip>
@@ -2638,13 +2638,13 @@
       <dgm:prSet presAssocID="{9A018547-60C4-470E-8D8D-20B4E52C0EC5}" presName="iconRect" presStyleLbl="node1" presStyleIdx="2" presStyleCnt="3"/>
       <dgm:spPr>
         <a:blipFill>
-          <a:blip xmlns:r="http://schemas.openxmlformats.org/officeDocument/2006/relationships" r:embed="rId6">
+          <a:blip xmlns:r="http://schemas.openxmlformats.org/officeDocument/2006/relationships">
             <a:extLst>
               <a:ext uri="{28A0092B-C50C-407E-A947-70E740481C1C}">
                 <a14:useLocalDpi xmlns:a14="http://schemas.microsoft.com/office/drawing/2010/main" val="0"/>
               </a:ext>
               <a:ext uri="{96DAC541-7B7A-43D3-8B79-37D633B846F1}">
-                <asvg:svgBlip xmlns:asvg="http://schemas.microsoft.com/office/drawing/2016/SVG/main" r:embed="rId7"/>
+                <asvg:svgBlip xmlns:asvg="http://schemas.microsoft.com/office/drawing/2016/SVG/main" r:embed="rId4"/>
               </a:ext>
             </a:extLst>
           </a:blip>
@@ -2716,47 +2716,60 @@
   <dgm:whole/>
   <dgm:extLst>
     <a:ext uri="http://schemas.microsoft.com/office/drawing/2008/diagram">
-      <dsp:dataModelExt xmlns:dsp="http://schemas.microsoft.com/office/drawing/2008/diagram" relId="rId5" minVer="http://schemas.openxmlformats.org/drawingml/2006/diagram"/>
+      <dsp:dataModelExt xmlns:dsp="http://schemas.microsoft.com/office/drawing/2008/diagram" relId="rId6" minVer="http://schemas.openxmlformats.org/drawingml/2006/diagram"/>
     </a:ext>
   </dgm:extLst>
 </dgm:dataModel>
 </file>
 
 <file path=ppt/diagrams/drawing1.xml><?xml version="1.0" encoding="utf-8"?>
-<dsp:drawing xmlns:dgm="http://schemas.openxmlformats.org/drawingml/2006/diagram" xmlns:dsp="http://schemas.microsoft.com/office/drawing/2008/diagram" xmlns:a="http://schemas.openxmlformats.org/drawingml/2006/main" xmlns:r="http://schemas.openxmlformats.org/officeDocument/2006/relationships">
+<dsp:drawing xmlns:dgm="http://schemas.openxmlformats.org/drawingml/2006/diagram" xmlns:dsp="http://schemas.microsoft.com/office/drawing/2008/diagram" xmlns:a="http://schemas.openxmlformats.org/drawingml/2006/main">
   <dsp:spTree>
     <dsp:nvGrpSpPr>
-      <dsp:cNvPr id="2" name="组合 1"/>
+      <dsp:cNvPr id="0" name=""/>
       <dsp:cNvGrpSpPr/>
     </dsp:nvGrpSpPr>
-    <dsp:grpSpPr>
-      <a:xfrm>
-        <a:off x="0" y="0"/>
-        <a:ext cx="7886700" cy="4351338"/>
-        <a:chOff x="0" y="0"/>
-        <a:chExt cx="7886700" cy="4351338"/>
-      </a:xfrm>
-    </dsp:grpSpPr>
+    <dsp:grpSpPr/>
     <dsp:sp modelId="{C967D384-CB09-3149-A7D4-9AA74AE3401B}">
       <dsp:nvSpPr>
-        <dsp:cNvPr id="3" name="矩形 2"/>
+        <dsp:cNvPr id="0" name=""/>
         <dsp:cNvSpPr/>
       </dsp:nvSpPr>
       <dsp:spPr bwMode="white">
         <a:xfrm>
-          <a:off x="0" y="1196267"/>
-          <a:ext cx="1784321" cy="547200"/>
+          <a:off x="2965" y="1146519"/>
+          <a:ext cx="1782979" cy="576000"/>
         </a:xfrm>
         <a:prstGeom prst="rect">
           <a:avLst/>
         </a:prstGeom>
+        <a:solidFill>
+          <a:schemeClr val="dk2">
+            <a:hueOff val="0"/>
+            <a:satOff val="0"/>
+            <a:lumOff val="0"/>
+            <a:alphaOff val="0"/>
+          </a:schemeClr>
+        </a:solidFill>
+        <a:ln w="25400" cap="flat" cmpd="sng" algn="ctr">
+          <a:solidFill>
+            <a:schemeClr val="dk2">
+              <a:hueOff val="0"/>
+              <a:satOff val="0"/>
+              <a:lumOff val="0"/>
+              <a:alphaOff val="0"/>
+            </a:schemeClr>
+          </a:solidFill>
+          <a:prstDash val="solid"/>
+        </a:ln>
+        <a:effectLst/>
       </dsp:spPr>
       <dsp:style>
         <a:lnRef idx="2">
-          <a:schemeClr val="dk2"/>
+          <a:scrgbClr r="0" g="0" b="0"/>
         </a:lnRef>
         <a:fillRef idx="1">
-          <a:schemeClr val="dk2"/>
+          <a:scrgbClr r="0" g="0" b="0"/>
         </a:fillRef>
         <a:effectRef idx="0">
           <a:scrgbClr r="0" g="0" b="0"/>
@@ -2766,40 +2779,14 @@
         </a:fontRef>
       </dsp:style>
       <dsp:txBody>
-        <a:bodyPr lIns="135128" tIns="77216" rIns="135128" bIns="77216" anchor="ctr"/>
-        <a:lstStyle>
-          <a:lvl1pPr algn="ctr">
-            <a:defRPr sz="1900"/>
-          </a:lvl1pPr>
-          <a:lvl2pPr marL="114300" indent="-114300" algn="ctr">
-            <a:defRPr sz="1400"/>
-          </a:lvl2pPr>
-          <a:lvl3pPr marL="228600" indent="-114300" algn="ctr">
-            <a:defRPr sz="1400"/>
-          </a:lvl3pPr>
-          <a:lvl4pPr marL="342900" indent="-114300" algn="ctr">
-            <a:defRPr sz="1400"/>
-          </a:lvl4pPr>
-          <a:lvl5pPr marL="457200" indent="-114300" algn="ctr">
-            <a:defRPr sz="1400"/>
-          </a:lvl5pPr>
-          <a:lvl6pPr marL="571500" indent="-114300" algn="ctr">
-            <a:defRPr sz="1400"/>
-          </a:lvl6pPr>
-          <a:lvl7pPr marL="685800" indent="-114300" algn="ctr">
-            <a:defRPr sz="1400"/>
-          </a:lvl7pPr>
-          <a:lvl8pPr marL="800100" indent="-114300" algn="ctr">
-            <a:defRPr sz="1400"/>
-          </a:lvl8pPr>
-          <a:lvl9pPr marL="914400" indent="-114300" algn="ctr">
-            <a:defRPr sz="1400"/>
-          </a:lvl9pPr>
-        </a:lstStyle>
+        <a:bodyPr spcFirstLastPara="0" vert="horz" wrap="square" lIns="142240" tIns="81280" rIns="142240" bIns="81280" numCol="1" spcCol="1270" anchor="ctr" anchorCtr="0">
+          <a:noAutofit/>
+        </a:bodyPr>
+        <a:lstStyle/>
         <a:p>
-          <a:pPr lvl="0">
+          <a:pPr marL="0" lvl="0" indent="0" algn="ctr" defTabSz="889000">
             <a:lnSpc>
-              <a:spcPct val="100000"/>
+              <a:spcPct val="90000"/>
             </a:lnSpc>
             <a:spcBef>
               <a:spcPct val="0"/>
@@ -2807,44 +2794,63 @@
             <a:spcAft>
               <a:spcPct val="35000"/>
             </a:spcAft>
+            <a:buNone/>
           </a:pPr>
           <a:r>
-            <a:rPr lang="en-US"/>
+            <a:rPr lang="en-US" sz="2000" kern="1200"/>
             <a:t>简单工厂</a:t>
           </a:r>
         </a:p>
       </dsp:txBody>
       <dsp:txXfrm>
-        <a:off x="0" y="1196267"/>
-        <a:ext cx="1784321" cy="547200"/>
+        <a:off x="2965" y="1146519"/>
+        <a:ext cx="1782979" cy="576000"/>
       </dsp:txXfrm>
     </dsp:sp>
     <dsp:sp modelId="{1BBF8059-C08C-9D4A-9997-C2EB2329A722}">
       <dsp:nvSpPr>
-        <dsp:cNvPr id="4" name="矩形 3"/>
+        <dsp:cNvPr id="0" name=""/>
         <dsp:cNvSpPr/>
       </dsp:nvSpPr>
       <dsp:spPr bwMode="white">
         <a:xfrm>
-          <a:off x="0" y="1743466"/>
-          <a:ext cx="1784321" cy="1411605"/>
+          <a:off x="2965" y="1722519"/>
+          <a:ext cx="1782979" cy="1482299"/>
         </a:xfrm>
         <a:prstGeom prst="rect">
           <a:avLst/>
         </a:prstGeom>
+        <a:solidFill>
+          <a:schemeClr val="dk2">
+            <a:alpha val="90000"/>
+            <a:tint val="40000"/>
+            <a:hueOff val="0"/>
+            <a:satOff val="0"/>
+            <a:lumOff val="0"/>
+            <a:alphaOff val="0"/>
+          </a:schemeClr>
+        </a:solidFill>
+        <a:ln w="25400" cap="flat" cmpd="sng" algn="ctr">
+          <a:solidFill>
+            <a:schemeClr val="dk2">
+              <a:alpha val="90000"/>
+              <a:tint val="40000"/>
+              <a:hueOff val="0"/>
+              <a:satOff val="0"/>
+              <a:lumOff val="0"/>
+              <a:alphaOff val="0"/>
+            </a:schemeClr>
+          </a:solidFill>
+          <a:prstDash val="solid"/>
+        </a:ln>
+        <a:effectLst/>
       </dsp:spPr>
       <dsp:style>
         <a:lnRef idx="2">
-          <a:schemeClr val="dk2">
-            <a:alpha val="90000"/>
-            <a:tint val="40000"/>
-          </a:schemeClr>
+          <a:scrgbClr r="0" g="0" b="0"/>
         </a:lnRef>
         <a:fillRef idx="1">
-          <a:schemeClr val="dk2">
-            <a:alpha val="90000"/>
-            <a:tint val="40000"/>
-          </a:schemeClr>
+          <a:scrgbClr r="0" g="0" b="0"/>
         </a:fillRef>
         <a:effectRef idx="0">
           <a:scrgbClr r="0" g="0" b="0"/>
@@ -2852,40 +2858,14 @@
         <a:fontRef idx="minor"/>
       </dsp:style>
       <dsp:txBody>
-        <a:bodyPr lIns="101346" tIns="101346" rIns="135128" bIns="152019" anchor="t"/>
-        <a:lstStyle>
-          <a:lvl1pPr algn="l">
-            <a:defRPr sz="1900"/>
-          </a:lvl1pPr>
-          <a:lvl2pPr marL="171450" indent="-171450" algn="l">
-            <a:defRPr sz="1900"/>
-          </a:lvl2pPr>
-          <a:lvl3pPr marL="342900" indent="-171450" algn="l">
-            <a:defRPr sz="1900"/>
-          </a:lvl3pPr>
-          <a:lvl4pPr marL="514350" indent="-171450" algn="l">
-            <a:defRPr sz="1900"/>
-          </a:lvl4pPr>
-          <a:lvl5pPr marL="685800" indent="-171450" algn="l">
-            <a:defRPr sz="1900"/>
-          </a:lvl5pPr>
-          <a:lvl6pPr marL="857250" indent="-171450" algn="l">
-            <a:defRPr sz="1900"/>
-          </a:lvl6pPr>
-          <a:lvl7pPr marL="1028700" indent="-171450" algn="l">
-            <a:defRPr sz="1900"/>
-          </a:lvl7pPr>
-          <a:lvl8pPr marL="1200150" indent="-171450" algn="l">
-            <a:defRPr sz="1900"/>
-          </a:lvl8pPr>
-          <a:lvl9pPr marL="1371600" indent="-171450" algn="l">
-            <a:defRPr sz="1900"/>
-          </a:lvl9pPr>
-        </a:lstStyle>
+        <a:bodyPr spcFirstLastPara="0" vert="horz" wrap="square" lIns="106680" tIns="106680" rIns="142240" bIns="160020" numCol="1" spcCol="1270" anchor="t" anchorCtr="0">
+          <a:noAutofit/>
+        </a:bodyPr>
+        <a:lstStyle/>
         <a:p>
-          <a:pPr lvl="1">
+          <a:pPr marL="228600" lvl="1" indent="-228600" algn="l" defTabSz="889000">
             <a:lnSpc>
-              <a:spcPct val="100000"/>
+              <a:spcPct val="90000"/>
             </a:lnSpc>
             <a:spcBef>
               <a:spcPct val="0"/>
@@ -2896,45 +2876,56 @@
             <a:buChar char="•"/>
           </a:pPr>
           <a:r>
-            <a:rPr lang="en-US">
-              <a:solidFill>
-                <a:schemeClr val="dk1"/>
-              </a:solidFill>
-            </a:rPr>
+            <a:rPr lang="en-US" sz="2000" kern="1200"/>
             <a:t>BeanFactory</a:t>
           </a:r>
-          <a:endParaRPr>
-            <a:solidFill>
-              <a:schemeClr val="dk1"/>
-            </a:solidFill>
-          </a:endParaRPr>
         </a:p>
       </dsp:txBody>
       <dsp:txXfrm>
-        <a:off x="0" y="1743466"/>
-        <a:ext cx="1784321" cy="1411605"/>
+        <a:off x="2965" y="1722519"/>
+        <a:ext cx="1782979" cy="1482299"/>
       </dsp:txXfrm>
     </dsp:sp>
     <dsp:sp modelId="{C6D35792-7A59-F840-AD55-7079BCDC9D8C}">
       <dsp:nvSpPr>
-        <dsp:cNvPr id="5" name="矩形 4"/>
+        <dsp:cNvPr id="0" name=""/>
         <dsp:cNvSpPr/>
       </dsp:nvSpPr>
       <dsp:spPr bwMode="white">
         <a:xfrm>
-          <a:off x="2034126" y="1196267"/>
-          <a:ext cx="1784321" cy="547200"/>
+          <a:off x="2035561" y="1146519"/>
+          <a:ext cx="1782979" cy="576000"/>
         </a:xfrm>
         <a:prstGeom prst="rect">
           <a:avLst/>
         </a:prstGeom>
+        <a:solidFill>
+          <a:schemeClr val="dk2">
+            <a:hueOff val="0"/>
+            <a:satOff val="0"/>
+            <a:lumOff val="0"/>
+            <a:alphaOff val="0"/>
+          </a:schemeClr>
+        </a:solidFill>
+        <a:ln w="25400" cap="flat" cmpd="sng" algn="ctr">
+          <a:solidFill>
+            <a:schemeClr val="dk2">
+              <a:hueOff val="0"/>
+              <a:satOff val="0"/>
+              <a:lumOff val="0"/>
+              <a:alphaOff val="0"/>
+            </a:schemeClr>
+          </a:solidFill>
+          <a:prstDash val="solid"/>
+        </a:ln>
+        <a:effectLst/>
       </dsp:spPr>
       <dsp:style>
         <a:lnRef idx="2">
-          <a:schemeClr val="dk2"/>
+          <a:scrgbClr r="0" g="0" b="0"/>
         </a:lnRef>
         <a:fillRef idx="1">
-          <a:schemeClr val="dk2"/>
+          <a:scrgbClr r="0" g="0" b="0"/>
         </a:fillRef>
         <a:effectRef idx="0">
           <a:scrgbClr r="0" g="0" b="0"/>
@@ -2944,40 +2935,14 @@
         </a:fontRef>
       </dsp:style>
       <dsp:txBody>
-        <a:bodyPr lIns="135128" tIns="77216" rIns="135128" bIns="77216" anchor="ctr"/>
-        <a:lstStyle>
-          <a:lvl1pPr algn="ctr">
-            <a:defRPr sz="1900"/>
-          </a:lvl1pPr>
-          <a:lvl2pPr marL="114300" indent="-114300" algn="ctr">
-            <a:defRPr sz="1400"/>
-          </a:lvl2pPr>
-          <a:lvl3pPr marL="228600" indent="-114300" algn="ctr">
-            <a:defRPr sz="1400"/>
-          </a:lvl3pPr>
-          <a:lvl4pPr marL="342900" indent="-114300" algn="ctr">
-            <a:defRPr sz="1400"/>
-          </a:lvl4pPr>
-          <a:lvl5pPr marL="457200" indent="-114300" algn="ctr">
-            <a:defRPr sz="1400"/>
-          </a:lvl5pPr>
-          <a:lvl6pPr marL="571500" indent="-114300" algn="ctr">
-            <a:defRPr sz="1400"/>
-          </a:lvl6pPr>
-          <a:lvl7pPr marL="685800" indent="-114300" algn="ctr">
-            <a:defRPr sz="1400"/>
-          </a:lvl7pPr>
-          <a:lvl8pPr marL="800100" indent="-114300" algn="ctr">
-            <a:defRPr sz="1400"/>
-          </a:lvl8pPr>
-          <a:lvl9pPr marL="914400" indent="-114300" algn="ctr">
-            <a:defRPr sz="1400"/>
-          </a:lvl9pPr>
-        </a:lstStyle>
+        <a:bodyPr spcFirstLastPara="0" vert="horz" wrap="square" lIns="142240" tIns="81280" rIns="142240" bIns="81280" numCol="1" spcCol="1270" anchor="ctr" anchorCtr="0">
+          <a:noAutofit/>
+        </a:bodyPr>
+        <a:lstStyle/>
         <a:p>
-          <a:pPr lvl="0">
+          <a:pPr marL="0" lvl="0" indent="0" algn="ctr" defTabSz="889000">
             <a:lnSpc>
-              <a:spcPct val="100000"/>
+              <a:spcPct val="90000"/>
             </a:lnSpc>
             <a:spcBef>
               <a:spcPct val="0"/>
@@ -2985,44 +2950,63 @@
             <a:spcAft>
               <a:spcPct val="35000"/>
             </a:spcAft>
+            <a:buNone/>
           </a:pPr>
           <a:r>
-            <a:rPr lang="en-US"/>
+            <a:rPr lang="en-US" sz="2000" kern="1200"/>
             <a:t>工厂模式</a:t>
           </a:r>
         </a:p>
       </dsp:txBody>
       <dsp:txXfrm>
-        <a:off x="2034126" y="1196267"/>
-        <a:ext cx="1784321" cy="547200"/>
+        <a:off x="2035561" y="1146519"/>
+        <a:ext cx="1782979" cy="576000"/>
       </dsp:txXfrm>
     </dsp:sp>
     <dsp:sp modelId="{B6B20EF0-C53E-C14D-A740-985BE4AFF0E7}">
       <dsp:nvSpPr>
-        <dsp:cNvPr id="6" name="矩形 5"/>
+        <dsp:cNvPr id="0" name=""/>
         <dsp:cNvSpPr/>
       </dsp:nvSpPr>
       <dsp:spPr bwMode="white">
         <a:xfrm>
-          <a:off x="2034126" y="1743466"/>
-          <a:ext cx="1784321" cy="1411605"/>
+          <a:off x="2035561" y="1722519"/>
+          <a:ext cx="1782979" cy="1482299"/>
         </a:xfrm>
         <a:prstGeom prst="rect">
           <a:avLst/>
         </a:prstGeom>
+        <a:solidFill>
+          <a:schemeClr val="dk2">
+            <a:alpha val="90000"/>
+            <a:tint val="40000"/>
+            <a:hueOff val="0"/>
+            <a:satOff val="0"/>
+            <a:lumOff val="0"/>
+            <a:alphaOff val="0"/>
+          </a:schemeClr>
+        </a:solidFill>
+        <a:ln w="25400" cap="flat" cmpd="sng" algn="ctr">
+          <a:solidFill>
+            <a:schemeClr val="dk2">
+              <a:alpha val="90000"/>
+              <a:tint val="40000"/>
+              <a:hueOff val="0"/>
+              <a:satOff val="0"/>
+              <a:lumOff val="0"/>
+              <a:alphaOff val="0"/>
+            </a:schemeClr>
+          </a:solidFill>
+          <a:prstDash val="solid"/>
+        </a:ln>
+        <a:effectLst/>
       </dsp:spPr>
       <dsp:style>
         <a:lnRef idx="2">
-          <a:schemeClr val="dk2">
-            <a:alpha val="90000"/>
-            <a:tint val="40000"/>
-          </a:schemeClr>
+          <a:scrgbClr r="0" g="0" b="0"/>
         </a:lnRef>
         <a:fillRef idx="1">
-          <a:schemeClr val="dk2">
-            <a:alpha val="90000"/>
-            <a:tint val="40000"/>
-          </a:schemeClr>
+          <a:scrgbClr r="0" g="0" b="0"/>
         </a:fillRef>
         <a:effectRef idx="0">
           <a:scrgbClr r="0" g="0" b="0"/>
@@ -3030,40 +3014,14 @@
         <a:fontRef idx="minor"/>
       </dsp:style>
       <dsp:txBody>
-        <a:bodyPr lIns="101346" tIns="101346" rIns="135128" bIns="152019" anchor="t"/>
-        <a:lstStyle>
-          <a:lvl1pPr algn="l">
-            <a:defRPr sz="1900"/>
-          </a:lvl1pPr>
-          <a:lvl2pPr marL="171450" indent="-171450" algn="l">
-            <a:defRPr sz="1900"/>
-          </a:lvl2pPr>
-          <a:lvl3pPr marL="342900" indent="-171450" algn="l">
-            <a:defRPr sz="1900"/>
-          </a:lvl3pPr>
-          <a:lvl4pPr marL="514350" indent="-171450" algn="l">
-            <a:defRPr sz="1900"/>
-          </a:lvl4pPr>
-          <a:lvl5pPr marL="685800" indent="-171450" algn="l">
-            <a:defRPr sz="1900"/>
-          </a:lvl5pPr>
-          <a:lvl6pPr marL="857250" indent="-171450" algn="l">
-            <a:defRPr sz="1900"/>
-          </a:lvl6pPr>
-          <a:lvl7pPr marL="1028700" indent="-171450" algn="l">
-            <a:defRPr sz="1900"/>
-          </a:lvl7pPr>
-          <a:lvl8pPr marL="1200150" indent="-171450" algn="l">
-            <a:defRPr sz="1900"/>
-          </a:lvl8pPr>
-          <a:lvl9pPr marL="1371600" indent="-171450" algn="l">
-            <a:defRPr sz="1900"/>
-          </a:lvl9pPr>
-        </a:lstStyle>
+        <a:bodyPr spcFirstLastPara="0" vert="horz" wrap="square" lIns="106680" tIns="106680" rIns="142240" bIns="160020" numCol="1" spcCol="1270" anchor="t" anchorCtr="0">
+          <a:noAutofit/>
+        </a:bodyPr>
+        <a:lstStyle/>
         <a:p>
-          <a:pPr lvl="1">
+          <a:pPr marL="228600" lvl="1" indent="-228600" algn="l" defTabSz="889000">
             <a:lnSpc>
-              <a:spcPct val="100000"/>
+              <a:spcPct val="90000"/>
             </a:lnSpc>
             <a:spcBef>
               <a:spcPct val="0"/>
@@ -3074,45 +3032,56 @@
             <a:buChar char="•"/>
           </a:pPr>
           <a:r>
-            <a:rPr lang="en-US">
-              <a:solidFill>
-                <a:schemeClr val="dk1"/>
-              </a:solidFill>
-            </a:rPr>
+            <a:rPr lang="en-US" sz="2000" kern="1200"/>
             <a:t>FactoryBean</a:t>
           </a:r>
-          <a:endParaRPr>
-            <a:solidFill>
-              <a:schemeClr val="dk1"/>
-            </a:solidFill>
-          </a:endParaRPr>
         </a:p>
       </dsp:txBody>
       <dsp:txXfrm>
-        <a:off x="2034126" y="1743466"/>
-        <a:ext cx="1784321" cy="1411605"/>
+        <a:off x="2035561" y="1722519"/>
+        <a:ext cx="1782979" cy="1482299"/>
       </dsp:txXfrm>
     </dsp:sp>
     <dsp:sp modelId="{D076BCEF-0DAD-BB46-A0F2-7729B158C207}">
       <dsp:nvSpPr>
-        <dsp:cNvPr id="7" name="矩形 6"/>
+        <dsp:cNvPr id="0" name=""/>
         <dsp:cNvSpPr/>
       </dsp:nvSpPr>
       <dsp:spPr bwMode="white">
         <a:xfrm>
-          <a:off x="4068252" y="1196267"/>
-          <a:ext cx="1784321" cy="547200"/>
+          <a:off x="4068158" y="1146519"/>
+          <a:ext cx="1782979" cy="576000"/>
         </a:xfrm>
         <a:prstGeom prst="rect">
           <a:avLst/>
         </a:prstGeom>
+        <a:solidFill>
+          <a:schemeClr val="dk2">
+            <a:hueOff val="0"/>
+            <a:satOff val="0"/>
+            <a:lumOff val="0"/>
+            <a:alphaOff val="0"/>
+          </a:schemeClr>
+        </a:solidFill>
+        <a:ln w="25400" cap="flat" cmpd="sng" algn="ctr">
+          <a:solidFill>
+            <a:schemeClr val="dk2">
+              <a:hueOff val="0"/>
+              <a:satOff val="0"/>
+              <a:lumOff val="0"/>
+              <a:alphaOff val="0"/>
+            </a:schemeClr>
+          </a:solidFill>
+          <a:prstDash val="solid"/>
+        </a:ln>
+        <a:effectLst/>
       </dsp:spPr>
       <dsp:style>
         <a:lnRef idx="2">
-          <a:schemeClr val="dk2"/>
+          <a:scrgbClr r="0" g="0" b="0"/>
         </a:lnRef>
         <a:fillRef idx="1">
-          <a:schemeClr val="dk2"/>
+          <a:scrgbClr r="0" g="0" b="0"/>
         </a:fillRef>
         <a:effectRef idx="0">
           <a:scrgbClr r="0" g="0" b="0"/>
@@ -3122,40 +3091,14 @@
         </a:fontRef>
       </dsp:style>
       <dsp:txBody>
-        <a:bodyPr lIns="135128" tIns="77216" rIns="135128" bIns="77216" anchor="ctr"/>
-        <a:lstStyle>
-          <a:lvl1pPr algn="ctr">
-            <a:defRPr sz="1900"/>
-          </a:lvl1pPr>
-          <a:lvl2pPr marL="114300" indent="-114300" algn="ctr">
-            <a:defRPr sz="1400"/>
-          </a:lvl2pPr>
-          <a:lvl3pPr marL="228600" indent="-114300" algn="ctr">
-            <a:defRPr sz="1400"/>
-          </a:lvl3pPr>
-          <a:lvl4pPr marL="342900" indent="-114300" algn="ctr">
-            <a:defRPr sz="1400"/>
-          </a:lvl4pPr>
-          <a:lvl5pPr marL="457200" indent="-114300" algn="ctr">
-            <a:defRPr sz="1400"/>
-          </a:lvl5pPr>
-          <a:lvl6pPr marL="571500" indent="-114300" algn="ctr">
-            <a:defRPr sz="1400"/>
-          </a:lvl6pPr>
-          <a:lvl7pPr marL="685800" indent="-114300" algn="ctr">
-            <a:defRPr sz="1400"/>
-          </a:lvl7pPr>
-          <a:lvl8pPr marL="800100" indent="-114300" algn="ctr">
-            <a:defRPr sz="1400"/>
-          </a:lvl8pPr>
-          <a:lvl9pPr marL="914400" indent="-114300" algn="ctr">
-            <a:defRPr sz="1400"/>
-          </a:lvl9pPr>
-        </a:lstStyle>
+        <a:bodyPr spcFirstLastPara="0" vert="horz" wrap="square" lIns="142240" tIns="81280" rIns="142240" bIns="81280" numCol="1" spcCol="1270" anchor="ctr" anchorCtr="0">
+          <a:noAutofit/>
+        </a:bodyPr>
+        <a:lstStyle/>
         <a:p>
-          <a:pPr lvl="0">
+          <a:pPr marL="0" lvl="0" indent="0" algn="ctr" defTabSz="889000">
             <a:lnSpc>
-              <a:spcPct val="100000"/>
+              <a:spcPct val="90000"/>
             </a:lnSpc>
             <a:spcBef>
               <a:spcPct val="0"/>
@@ -3163,44 +3106,63 @@
             <a:spcAft>
               <a:spcPct val="35000"/>
             </a:spcAft>
+            <a:buNone/>
           </a:pPr>
           <a:r>
-            <a:rPr lang="en-US"/>
+            <a:rPr lang="en-US" sz="2000" kern="1200"/>
             <a:t>代理模式</a:t>
           </a:r>
         </a:p>
       </dsp:txBody>
       <dsp:txXfrm>
-        <a:off x="4068252" y="1196267"/>
-        <a:ext cx="1784321" cy="547200"/>
+        <a:off x="4068158" y="1146519"/>
+        <a:ext cx="1782979" cy="576000"/>
       </dsp:txXfrm>
     </dsp:sp>
     <dsp:sp modelId="{3CBCF33C-2970-AA47-A594-801F2DAD9145}">
       <dsp:nvSpPr>
-        <dsp:cNvPr id="8" name="矩形 7"/>
+        <dsp:cNvPr id="0" name=""/>
         <dsp:cNvSpPr/>
       </dsp:nvSpPr>
       <dsp:spPr bwMode="white">
         <a:xfrm>
-          <a:off x="4068252" y="1743466"/>
-          <a:ext cx="1784321" cy="1411605"/>
+          <a:off x="4068158" y="1722519"/>
+          <a:ext cx="1782979" cy="1482299"/>
         </a:xfrm>
         <a:prstGeom prst="rect">
           <a:avLst/>
         </a:prstGeom>
+        <a:solidFill>
+          <a:schemeClr val="dk2">
+            <a:alpha val="90000"/>
+            <a:tint val="40000"/>
+            <a:hueOff val="0"/>
+            <a:satOff val="0"/>
+            <a:lumOff val="0"/>
+            <a:alphaOff val="0"/>
+          </a:schemeClr>
+        </a:solidFill>
+        <a:ln w="25400" cap="flat" cmpd="sng" algn="ctr">
+          <a:solidFill>
+            <a:schemeClr val="dk2">
+              <a:alpha val="90000"/>
+              <a:tint val="40000"/>
+              <a:hueOff val="0"/>
+              <a:satOff val="0"/>
+              <a:lumOff val="0"/>
+              <a:alphaOff val="0"/>
+            </a:schemeClr>
+          </a:solidFill>
+          <a:prstDash val="solid"/>
+        </a:ln>
+        <a:effectLst/>
       </dsp:spPr>
       <dsp:style>
         <a:lnRef idx="2">
-          <a:schemeClr val="dk2">
-            <a:alpha val="90000"/>
-            <a:tint val="40000"/>
-          </a:schemeClr>
+          <a:scrgbClr r="0" g="0" b="0"/>
         </a:lnRef>
         <a:fillRef idx="1">
-          <a:schemeClr val="dk2">
-            <a:alpha val="90000"/>
-            <a:tint val="40000"/>
-          </a:schemeClr>
+          <a:scrgbClr r="0" g="0" b="0"/>
         </a:fillRef>
         <a:effectRef idx="0">
           <a:scrgbClr r="0" g="0" b="0"/>
@@ -3208,40 +3170,14 @@
         <a:fontRef idx="minor"/>
       </dsp:style>
       <dsp:txBody>
-        <a:bodyPr lIns="101346" tIns="101346" rIns="135128" bIns="152019" anchor="t"/>
-        <a:lstStyle>
-          <a:lvl1pPr algn="l">
-            <a:defRPr sz="1900"/>
-          </a:lvl1pPr>
-          <a:lvl2pPr marL="171450" indent="-171450" algn="l">
-            <a:defRPr sz="1900"/>
-          </a:lvl2pPr>
-          <a:lvl3pPr marL="342900" indent="-171450" algn="l">
-            <a:defRPr sz="1900"/>
-          </a:lvl3pPr>
-          <a:lvl4pPr marL="514350" indent="-171450" algn="l">
-            <a:defRPr sz="1900"/>
-          </a:lvl4pPr>
-          <a:lvl5pPr marL="685800" indent="-171450" algn="l">
-            <a:defRPr sz="1900"/>
-          </a:lvl5pPr>
-          <a:lvl6pPr marL="857250" indent="-171450" algn="l">
-            <a:defRPr sz="1900"/>
-          </a:lvl6pPr>
-          <a:lvl7pPr marL="1028700" indent="-171450" algn="l">
-            <a:defRPr sz="1900"/>
-          </a:lvl7pPr>
-          <a:lvl8pPr marL="1200150" indent="-171450" algn="l">
-            <a:defRPr sz="1900"/>
-          </a:lvl8pPr>
-          <a:lvl9pPr marL="1371600" indent="-171450" algn="l">
-            <a:defRPr sz="1900"/>
-          </a:lvl9pPr>
-        </a:lstStyle>
+        <a:bodyPr spcFirstLastPara="0" vert="horz" wrap="square" lIns="106680" tIns="106680" rIns="142240" bIns="160020" numCol="1" spcCol="1270" anchor="t" anchorCtr="0">
+          <a:noAutofit/>
+        </a:bodyPr>
+        <a:lstStyle/>
         <a:p>
-          <a:pPr lvl="1">
+          <a:pPr marL="228600" lvl="1" indent="-228600" algn="l" defTabSz="889000">
             <a:lnSpc>
-              <a:spcPct val="100000"/>
+              <a:spcPct val="90000"/>
             </a:lnSpc>
             <a:spcBef>
               <a:spcPct val="0"/>
@@ -3252,53 +3188,61 @@
             <a:buChar char="•"/>
           </a:pPr>
           <a:r>
-            <a:rPr lang="en-US">
-              <a:solidFill>
-                <a:schemeClr val="dk1"/>
-              </a:solidFill>
-            </a:rPr>
+            <a:rPr lang="en-US" sz="2000" kern="1200"/>
             <a:t>AOP</a:t>
           </a:r>
           <a:r>
-            <a:rPr lang="zh-CN">
-              <a:solidFill>
-                <a:schemeClr val="dk1"/>
-              </a:solidFill>
-            </a:rPr>
+            <a:rPr lang="zh-CN" sz="2000" kern="1200"/>
             <a:t>底层，就是动态代理模式的实现。</a:t>
           </a:r>
-          <a:endParaRPr lang="en-US">
-            <a:solidFill>
-              <a:schemeClr val="dk1"/>
-            </a:solidFill>
-          </a:endParaRPr>
+          <a:endParaRPr lang="en-US" sz="2000" kern="1200"/>
         </a:p>
       </dsp:txBody>
       <dsp:txXfrm>
-        <a:off x="4068252" y="1743466"/>
-        <a:ext cx="1784321" cy="1411605"/>
+        <a:off x="4068158" y="1722519"/>
+        <a:ext cx="1782979" cy="1482299"/>
       </dsp:txXfrm>
     </dsp:sp>
     <dsp:sp modelId="{8283BB38-B061-0C49-8900-474EBBCE9E02}">
       <dsp:nvSpPr>
-        <dsp:cNvPr id="9" name="矩形 8"/>
+        <dsp:cNvPr id="0" name=""/>
         <dsp:cNvSpPr/>
       </dsp:nvSpPr>
       <dsp:spPr bwMode="white">
         <a:xfrm>
-          <a:off x="6102379" y="1196267"/>
-          <a:ext cx="1784321" cy="547200"/>
+          <a:off x="6100755" y="1146519"/>
+          <a:ext cx="1782979" cy="576000"/>
         </a:xfrm>
         <a:prstGeom prst="rect">
           <a:avLst/>
         </a:prstGeom>
+        <a:solidFill>
+          <a:schemeClr val="dk2">
+            <a:hueOff val="0"/>
+            <a:satOff val="0"/>
+            <a:lumOff val="0"/>
+            <a:alphaOff val="0"/>
+          </a:schemeClr>
+        </a:solidFill>
+        <a:ln w="25400" cap="flat" cmpd="sng" algn="ctr">
+          <a:solidFill>
+            <a:schemeClr val="dk2">
+              <a:hueOff val="0"/>
+              <a:satOff val="0"/>
+              <a:lumOff val="0"/>
+              <a:alphaOff val="0"/>
+            </a:schemeClr>
+          </a:solidFill>
+          <a:prstDash val="solid"/>
+        </a:ln>
+        <a:effectLst/>
       </dsp:spPr>
       <dsp:style>
         <a:lnRef idx="2">
-          <a:schemeClr val="dk2"/>
+          <a:scrgbClr r="0" g="0" b="0"/>
         </a:lnRef>
         <a:fillRef idx="1">
-          <a:schemeClr val="dk2"/>
+          <a:scrgbClr r="0" g="0" b="0"/>
         </a:fillRef>
         <a:effectRef idx="0">
           <a:scrgbClr r="0" g="0" b="0"/>
@@ -3308,40 +3252,14 @@
         </a:fontRef>
       </dsp:style>
       <dsp:txBody>
-        <a:bodyPr lIns="135128" tIns="77216" rIns="135128" bIns="77216" anchor="ctr"/>
-        <a:lstStyle>
-          <a:lvl1pPr algn="ctr">
-            <a:defRPr sz="1900"/>
-          </a:lvl1pPr>
-          <a:lvl2pPr marL="114300" indent="-114300" algn="ctr">
-            <a:defRPr sz="1400"/>
-          </a:lvl2pPr>
-          <a:lvl3pPr marL="228600" indent="-114300" algn="ctr">
-            <a:defRPr sz="1400"/>
-          </a:lvl3pPr>
-          <a:lvl4pPr marL="342900" indent="-114300" algn="ctr">
-            <a:defRPr sz="1400"/>
-          </a:lvl4pPr>
-          <a:lvl5pPr marL="457200" indent="-114300" algn="ctr">
-            <a:defRPr sz="1400"/>
-          </a:lvl5pPr>
-          <a:lvl6pPr marL="571500" indent="-114300" algn="ctr">
-            <a:defRPr sz="1400"/>
-          </a:lvl6pPr>
-          <a:lvl7pPr marL="685800" indent="-114300" algn="ctr">
-            <a:defRPr sz="1400"/>
-          </a:lvl7pPr>
-          <a:lvl8pPr marL="800100" indent="-114300" algn="ctr">
-            <a:defRPr sz="1400"/>
-          </a:lvl8pPr>
-          <a:lvl9pPr marL="914400" indent="-114300" algn="ctr">
-            <a:defRPr sz="1400"/>
-          </a:lvl9pPr>
-        </a:lstStyle>
+        <a:bodyPr spcFirstLastPara="0" vert="horz" wrap="square" lIns="142240" tIns="81280" rIns="142240" bIns="81280" numCol="1" spcCol="1270" anchor="ctr" anchorCtr="0">
+          <a:noAutofit/>
+        </a:bodyPr>
+        <a:lstStyle/>
         <a:p>
-          <a:pPr lvl="0">
+          <a:pPr marL="0" lvl="0" indent="0" algn="ctr" defTabSz="889000">
             <a:lnSpc>
-              <a:spcPct val="100000"/>
+              <a:spcPct val="90000"/>
             </a:lnSpc>
             <a:spcBef>
               <a:spcPct val="0"/>
@@ -3349,44 +3267,63 @@
             <a:spcAft>
               <a:spcPct val="35000"/>
             </a:spcAft>
+            <a:buNone/>
           </a:pPr>
           <a:r>
-            <a:rPr lang="en-US"/>
+            <a:rPr lang="en-US" sz="2000" kern="1200"/>
             <a:t>单例模式</a:t>
           </a:r>
         </a:p>
       </dsp:txBody>
       <dsp:txXfrm>
-        <a:off x="6102379" y="1196267"/>
-        <a:ext cx="1784321" cy="547200"/>
+        <a:off x="6100755" y="1146519"/>
+        <a:ext cx="1782979" cy="576000"/>
       </dsp:txXfrm>
     </dsp:sp>
     <dsp:sp modelId="{77D92599-0B21-3C40-8EB1-015E04C3DE2D}">
       <dsp:nvSpPr>
-        <dsp:cNvPr id="10" name="矩形 9"/>
+        <dsp:cNvPr id="0" name=""/>
         <dsp:cNvSpPr/>
       </dsp:nvSpPr>
       <dsp:spPr bwMode="white">
         <a:xfrm>
-          <a:off x="6102379" y="1743466"/>
-          <a:ext cx="1784321" cy="1411605"/>
+          <a:off x="6100755" y="1722519"/>
+          <a:ext cx="1782979" cy="1482299"/>
         </a:xfrm>
         <a:prstGeom prst="rect">
           <a:avLst/>
         </a:prstGeom>
+        <a:solidFill>
+          <a:schemeClr val="dk2">
+            <a:alpha val="90000"/>
+            <a:tint val="40000"/>
+            <a:hueOff val="0"/>
+            <a:satOff val="0"/>
+            <a:lumOff val="0"/>
+            <a:alphaOff val="0"/>
+          </a:schemeClr>
+        </a:solidFill>
+        <a:ln w="25400" cap="flat" cmpd="sng" algn="ctr">
+          <a:solidFill>
+            <a:schemeClr val="dk2">
+              <a:alpha val="90000"/>
+              <a:tint val="40000"/>
+              <a:hueOff val="0"/>
+              <a:satOff val="0"/>
+              <a:lumOff val="0"/>
+              <a:alphaOff val="0"/>
+            </a:schemeClr>
+          </a:solidFill>
+          <a:prstDash val="solid"/>
+        </a:ln>
+        <a:effectLst/>
       </dsp:spPr>
       <dsp:style>
         <a:lnRef idx="2">
-          <a:schemeClr val="dk2">
-            <a:alpha val="90000"/>
-            <a:tint val="40000"/>
-          </a:schemeClr>
+          <a:scrgbClr r="0" g="0" b="0"/>
         </a:lnRef>
         <a:fillRef idx="1">
-          <a:schemeClr val="dk2">
-            <a:alpha val="90000"/>
-            <a:tint val="40000"/>
-          </a:schemeClr>
+          <a:scrgbClr r="0" g="0" b="0"/>
         </a:fillRef>
         <a:effectRef idx="0">
           <a:scrgbClr r="0" g="0" b="0"/>
@@ -3394,40 +3331,14 @@
         <a:fontRef idx="minor"/>
       </dsp:style>
       <dsp:txBody>
-        <a:bodyPr lIns="101346" tIns="101346" rIns="135128" bIns="152019" anchor="t"/>
-        <a:lstStyle>
-          <a:lvl1pPr algn="l">
-            <a:defRPr sz="1900"/>
-          </a:lvl1pPr>
-          <a:lvl2pPr marL="171450" indent="-171450" algn="l">
-            <a:defRPr sz="1900"/>
-          </a:lvl2pPr>
-          <a:lvl3pPr marL="342900" indent="-171450" algn="l">
-            <a:defRPr sz="1900"/>
-          </a:lvl3pPr>
-          <a:lvl4pPr marL="514350" indent="-171450" algn="l">
-            <a:defRPr sz="1900"/>
-          </a:lvl4pPr>
-          <a:lvl5pPr marL="685800" indent="-171450" algn="l">
-            <a:defRPr sz="1900"/>
-          </a:lvl5pPr>
-          <a:lvl6pPr marL="857250" indent="-171450" algn="l">
-            <a:defRPr sz="1900"/>
-          </a:lvl6pPr>
-          <a:lvl7pPr marL="1028700" indent="-171450" algn="l">
-            <a:defRPr sz="1900"/>
-          </a:lvl7pPr>
-          <a:lvl8pPr marL="1200150" indent="-171450" algn="l">
-            <a:defRPr sz="1900"/>
-          </a:lvl8pPr>
-          <a:lvl9pPr marL="1371600" indent="-171450" algn="l">
-            <a:defRPr sz="1900"/>
-          </a:lvl9pPr>
-        </a:lstStyle>
+        <a:bodyPr spcFirstLastPara="0" vert="horz" wrap="square" lIns="106680" tIns="106680" rIns="142240" bIns="160020" numCol="1" spcCol="1270" anchor="t" anchorCtr="0">
+          <a:noAutofit/>
+        </a:bodyPr>
+        <a:lstStyle/>
         <a:p>
-          <a:pPr lvl="1">
+          <a:pPr marL="228600" lvl="1" indent="-228600" algn="l" defTabSz="889000">
             <a:lnSpc>
-              <a:spcPct val="100000"/>
+              <a:spcPct val="90000"/>
             </a:lnSpc>
             <a:spcBef>
               <a:spcPct val="0"/>
@@ -3438,31 +3349,19 @@
             <a:buChar char="•"/>
           </a:pPr>
           <a:r>
-            <a:rPr lang="en-US">
-              <a:solidFill>
-                <a:schemeClr val="dk1"/>
-              </a:solidFill>
-            </a:rPr>
+            <a:rPr lang="en-US" sz="2000" kern="1200"/>
             <a:t>Bean</a:t>
           </a:r>
           <a:r>
-            <a:rPr lang="zh-CN">
-              <a:solidFill>
-                <a:schemeClr val="dk1"/>
-              </a:solidFill>
-            </a:rPr>
+            <a:rPr lang="zh-CN" sz="2000" kern="1200"/>
             <a:t> 默认单例</a:t>
           </a:r>
-          <a:endParaRPr lang="en-US">
-            <a:solidFill>
-              <a:schemeClr val="dk1"/>
-            </a:solidFill>
-          </a:endParaRPr>
+          <a:endParaRPr lang="en-US" sz="2000" kern="1200"/>
         </a:p>
       </dsp:txBody>
       <dsp:txXfrm>
-        <a:off x="6102379" y="1743466"/>
-        <a:ext cx="1784321" cy="1411605"/>
+        <a:off x="6100755" y="1722519"/>
+        <a:ext cx="1782979" cy="1482299"/>
       </dsp:txXfrm>
     </dsp:sp>
   </dsp:spTree>
@@ -3470,41 +3369,34 @@
 </file>
 
 <file path=ppt/diagrams/drawing2.xml><?xml version="1.0" encoding="utf-8"?>
-<dsp:drawing xmlns:dgm="http://schemas.openxmlformats.org/drawingml/2006/diagram" xmlns:dsp="http://schemas.microsoft.com/office/drawing/2008/diagram" xmlns:a="http://schemas.openxmlformats.org/drawingml/2006/main" xmlns:r="http://schemas.openxmlformats.org/officeDocument/2006/relationships">
+<dsp:drawing xmlns:dgm="http://schemas.openxmlformats.org/drawingml/2006/diagram" xmlns:dsp="http://schemas.microsoft.com/office/drawing/2008/diagram" xmlns:a="http://schemas.openxmlformats.org/drawingml/2006/main">
   <dsp:spTree>
     <dsp:nvGrpSpPr>
-      <dsp:cNvPr id="2" name="组合 1"/>
+      <dsp:cNvPr id="0" name=""/>
       <dsp:cNvGrpSpPr/>
     </dsp:nvGrpSpPr>
-    <dsp:grpSpPr>
-      <a:xfrm>
-        <a:off x="0" y="0"/>
-        <a:ext cx="8195871" cy="4192805"/>
-        <a:chOff x="0" y="0"/>
-        <a:chExt cx="8195871" cy="4192805"/>
-      </a:xfrm>
-    </dsp:grpSpPr>
+    <dsp:grpSpPr/>
     <dsp:sp modelId="{62B230F3-45D6-41FE-B916-108F1C6E49DA}">
       <dsp:nvSpPr>
-        <dsp:cNvPr id="3" name="矩形 2"/>
+        <dsp:cNvPr id="0" name=""/>
         <dsp:cNvSpPr/>
       </dsp:nvSpPr>
-      <dsp:spPr bwMode="white">
+      <dsp:spPr>
         <a:xfrm>
-          <a:off x="795122" y="1395149"/>
-          <a:ext cx="856285" cy="856285"/>
+          <a:off x="800349" y="1153021"/>
+          <a:ext cx="854929" cy="854929"/>
         </a:xfrm>
         <a:prstGeom prst="rect">
           <a:avLst/>
         </a:prstGeom>
         <a:blipFill>
-          <a:blip r:embed="rId1">
+          <a:blip xmlns:r="http://schemas.openxmlformats.org/officeDocument/2006/relationships">
             <a:extLst>
               <a:ext uri="{28A0092B-C50C-407E-A947-70E740481C1C}">
                 <a14:useLocalDpi xmlns:a14="http://schemas.microsoft.com/office/drawing/2010/main" val="0"/>
               </a:ext>
               <a:ext uri="{96DAC541-7B7A-43D3-8B79-37D633B846F1}">
-                <asvg:svgBlip xmlns:asvg="http://schemas.microsoft.com/office/drawing/2016/SVG/main" r:embed="rId2"/>
+                <asvg:svgBlip xmlns:asvg="http://schemas.microsoft.com/office/drawing/2016/SVG/main" r:embed="rId1"/>
               </a:ext>
             </a:extLst>
           </a:blip>
@@ -3512,18 +3404,18 @@
             <a:fillRect/>
           </a:stretch>
         </a:blipFill>
-        <a:ln>
+        <a:ln w="25400" cap="flat" cmpd="sng" algn="ctr">
           <a:noFill/>
+          <a:prstDash val="solid"/>
         </a:ln>
+        <a:effectLst/>
       </dsp:spPr>
       <dsp:style>
         <a:lnRef idx="2">
-          <a:schemeClr val="lt1">
-            <a:alpha val="0"/>
-          </a:schemeClr>
+          <a:scrgbClr r="0" g="0" b="0"/>
         </a:lnRef>
         <a:fillRef idx="1">
-          <a:schemeClr val="accent2"/>
+          <a:scrgbClr r="0" g="0" b="0"/>
         </a:fillRef>
         <a:effectRef idx="0">
           <a:scrgbClr r="0" g="0" b="0"/>
@@ -3532,35 +3424,32 @@
           <a:schemeClr val="lt1"/>
         </a:fontRef>
       </dsp:style>
-      <dsp:txXfrm>
-        <a:off x="795122" y="1395149"/>
-        <a:ext cx="856285" cy="856285"/>
-      </dsp:txXfrm>
     </dsp:sp>
     <dsp:sp modelId="{E7AD5A40-D786-4A66-B2D8-A7872E7DED9A}">
       <dsp:nvSpPr>
-        <dsp:cNvPr id="4" name="矩形 3"/>
+        <dsp:cNvPr id="0" name=""/>
         <dsp:cNvSpPr/>
       </dsp:nvSpPr>
-      <dsp:spPr bwMode="white">
+      <dsp:spPr>
         <a:xfrm>
-          <a:off x="0" y="2332565"/>
-          <a:ext cx="2446529" cy="427355"/>
+          <a:off x="6486" y="2089081"/>
+          <a:ext cx="2442656" cy="469447"/>
         </a:xfrm>
         <a:prstGeom prst="rect">
           <a:avLst/>
         </a:prstGeom>
+        <a:noFill/>
+        <a:ln>
+          <a:noFill/>
+        </a:ln>
+        <a:effectLst/>
       </dsp:spPr>
       <dsp:style>
         <a:lnRef idx="0">
-          <a:schemeClr val="dk1">
-            <a:alpha val="0"/>
-          </a:schemeClr>
+          <a:scrgbClr r="0" g="0" b="0"/>
         </a:lnRef>
         <a:fillRef idx="0">
-          <a:schemeClr val="lt1">
-            <a:alpha val="0"/>
-          </a:schemeClr>
+          <a:scrgbClr r="0" g="0" b="0"/>
         </a:fillRef>
         <a:effectRef idx="0">
           <a:scrgbClr r="0" g="0" b="0"/>
@@ -3568,38 +3457,12 @@
         <a:fontRef idx="minor"/>
       </dsp:style>
       <dsp:txBody>
-        <a:bodyPr lIns="0" tIns="0" rIns="0" bIns="0" anchor="t"/>
-        <a:lstStyle>
-          <a:lvl1pPr algn="ctr">
-            <a:defRPr sz="1400"/>
-          </a:lvl1pPr>
-          <a:lvl2pPr marL="57150" indent="-57150" algn="ctr">
-            <a:defRPr sz="1000"/>
-          </a:lvl2pPr>
-          <a:lvl3pPr marL="114300" indent="-57150" algn="ctr">
-            <a:defRPr sz="1000"/>
-          </a:lvl3pPr>
-          <a:lvl4pPr marL="171450" indent="-57150" algn="ctr">
-            <a:defRPr sz="1000"/>
-          </a:lvl4pPr>
-          <a:lvl5pPr marL="228600" indent="-57150" algn="ctr">
-            <a:defRPr sz="1000"/>
-          </a:lvl5pPr>
-          <a:lvl6pPr marL="285750" indent="-57150" algn="ctr">
-            <a:defRPr sz="1000"/>
-          </a:lvl6pPr>
-          <a:lvl7pPr marL="342900" indent="-57150" algn="ctr">
-            <a:defRPr sz="1000"/>
-          </a:lvl7pPr>
-          <a:lvl8pPr marL="400050" indent="-57150" algn="ctr">
-            <a:defRPr sz="1000"/>
-          </a:lvl8pPr>
-          <a:lvl9pPr marL="457200" indent="-57150" algn="ctr">
-            <a:defRPr sz="1000"/>
-          </a:lvl9pPr>
-        </a:lstStyle>
+        <a:bodyPr spcFirstLastPara="0" vert="horz" wrap="square" lIns="0" tIns="0" rIns="0" bIns="0" numCol="1" spcCol="1270" anchor="t" anchorCtr="0">
+          <a:noAutofit/>
+        </a:bodyPr>
+        <a:lstStyle/>
         <a:p>
-          <a:pPr lvl="0">
+          <a:pPr marL="0" lvl="0" indent="0" algn="ctr" defTabSz="622300">
             <a:lnSpc>
               <a:spcPct val="100000"/>
             </a:lnSpc>
@@ -3609,75 +3472,57 @@
             <a:spcAft>
               <a:spcPct val="35000"/>
             </a:spcAft>
+            <a:buNone/>
           </a:pPr>
           <a:r>
-            <a:rPr lang="en-US">
-              <a:solidFill>
-                <a:schemeClr val="tx1"/>
-              </a:solidFill>
-            </a:rPr>
+            <a:rPr lang="en-US" sz="1400" kern="1200"/>
             <a:t>MyBatis-Plus</a:t>
           </a:r>
           <a:r>
-            <a:rPr lang="zh-CN">
-              <a:solidFill>
-                <a:schemeClr val="tx1"/>
-              </a:solidFill>
-            </a:rPr>
+            <a:rPr lang="zh-CN" sz="1400" kern="1200"/>
             <a:t>：简化</a:t>
           </a:r>
           <a:r>
-            <a:rPr lang="en-US">
-              <a:solidFill>
-                <a:schemeClr val="tx1"/>
-              </a:solidFill>
-            </a:rPr>
+            <a:rPr lang="en-US" sz="1400" kern="1200"/>
             <a:t>dao</a:t>
           </a:r>
           <a:r>
-            <a:rPr lang="zh-CN">
-              <a:solidFill>
-                <a:schemeClr val="tx1"/>
-              </a:solidFill>
-            </a:rPr>
+            <a:rPr lang="zh-CN" sz="1400" kern="1200"/>
             <a:t>层代码的开发</a:t>
           </a:r>
-          <a:endParaRPr lang="en-US">
-            <a:solidFill>
-              <a:schemeClr val="tx1"/>
-            </a:solidFill>
-          </a:endParaRPr>
+          <a:endParaRPr lang="en-US" sz="1400" kern="1200"/>
         </a:p>
       </dsp:txBody>
       <dsp:txXfrm>
-        <a:off x="0" y="2332565"/>
-        <a:ext cx="2446529" cy="427355"/>
+        <a:off x="6486" y="2089081"/>
+        <a:ext cx="2442656" cy="469447"/>
       </dsp:txXfrm>
     </dsp:sp>
     <dsp:sp modelId="{0EF60DFB-5048-46CB-845E-A4AB22CBB503}">
       <dsp:nvSpPr>
-        <dsp:cNvPr id="5" name="矩形 4"/>
+        <dsp:cNvPr id="0" name=""/>
         <dsp:cNvSpPr/>
       </dsp:nvSpPr>
-      <dsp:spPr bwMode="white">
+      <dsp:spPr>
         <a:xfrm>
-          <a:off x="0" y="2797656"/>
-          <a:ext cx="2446529" cy="0"/>
+          <a:off x="6486" y="2596265"/>
+          <a:ext cx="2442656" cy="443518"/>
         </a:xfrm>
         <a:prstGeom prst="rect">
           <a:avLst/>
         </a:prstGeom>
+        <a:noFill/>
+        <a:ln>
+          <a:noFill/>
+        </a:ln>
+        <a:effectLst/>
       </dsp:spPr>
       <dsp:style>
         <a:lnRef idx="0">
-          <a:schemeClr val="dk1">
-            <a:alpha val="0"/>
-          </a:schemeClr>
+          <a:scrgbClr r="0" g="0" b="0"/>
         </a:lnRef>
         <a:fillRef idx="0">
-          <a:schemeClr val="lt1">
-            <a:alpha val="0"/>
-          </a:schemeClr>
+          <a:scrgbClr r="0" g="0" b="0"/>
         </a:fillRef>
         <a:effectRef idx="0">
           <a:scrgbClr r="0" g="0" b="0"/>
@@ -3685,38 +3530,12 @@
         <a:fontRef idx="minor"/>
       </dsp:style>
       <dsp:txBody>
-        <a:bodyPr lIns="0" tIns="0" rIns="0" bIns="0" anchor="t"/>
-        <a:lstStyle>
-          <a:lvl1pPr algn="ctr">
-            <a:defRPr sz="500"/>
-          </a:lvl1pPr>
-          <a:lvl2pPr marL="57150" indent="-57150" algn="ctr">
-            <a:defRPr sz="500"/>
-          </a:lvl2pPr>
-          <a:lvl3pPr marL="114300" indent="-57150" algn="ctr">
-            <a:defRPr sz="500"/>
-          </a:lvl3pPr>
-          <a:lvl4pPr marL="171450" indent="-57150" algn="ctr">
-            <a:defRPr sz="500"/>
-          </a:lvl4pPr>
-          <a:lvl5pPr marL="228600" indent="-57150" algn="ctr">
-            <a:defRPr sz="500"/>
-          </a:lvl5pPr>
-          <a:lvl6pPr marL="285750" indent="-57150" algn="ctr">
-            <a:defRPr sz="500"/>
-          </a:lvl6pPr>
-          <a:lvl7pPr marL="342900" indent="-57150" algn="ctr">
-            <a:defRPr sz="500"/>
-          </a:lvl7pPr>
-          <a:lvl8pPr marL="400050" indent="-57150" algn="ctr">
-            <a:defRPr sz="500"/>
-          </a:lvl8pPr>
-          <a:lvl9pPr marL="457200" indent="-57150" algn="ctr">
-            <a:defRPr sz="500"/>
-          </a:lvl9pPr>
-        </a:lstStyle>
+        <a:bodyPr spcFirstLastPara="0" vert="horz" wrap="square" lIns="0" tIns="0" rIns="0" bIns="0" numCol="1" spcCol="1270" anchor="t" anchorCtr="0">
+          <a:noAutofit/>
+        </a:bodyPr>
+        <a:lstStyle/>
         <a:p>
-          <a:pPr lvl="0">
+          <a:pPr marL="0" lvl="0" indent="0" algn="ctr" defTabSz="488950">
             <a:lnSpc>
               <a:spcPct val="100000"/>
             </a:lnSpc>
@@ -3726,49 +3545,43 @@
             <a:spcAft>
               <a:spcPct val="35000"/>
             </a:spcAft>
+            <a:buNone/>
           </a:pPr>
           <a:r>
-            <a:rPr lang="en-US">
-              <a:solidFill>
-                <a:schemeClr val="tx1"/>
-              </a:solidFill>
-              <a:hlinkClick r:id="rId3"/>
+            <a:rPr lang="en-US" sz="1100" kern="1200">
+              <a:hlinkClick xmlns:r="http://schemas.openxmlformats.org/officeDocument/2006/relationships" r:id="rId2"/>
             </a:rPr>
             <a:t>https://baomidou.com</a:t>
           </a:r>
-          <a:endParaRPr lang="en-US">
-            <a:solidFill>
-              <a:schemeClr val="tx1"/>
-            </a:solidFill>
-          </a:endParaRPr>
+          <a:endParaRPr lang="en-US" sz="1100" kern="1200"/>
         </a:p>
       </dsp:txBody>
       <dsp:txXfrm>
-        <a:off x="0" y="2797656"/>
-        <a:ext cx="2446529" cy="0"/>
+        <a:off x="6486" y="2596265"/>
+        <a:ext cx="2442656" cy="443518"/>
       </dsp:txXfrm>
     </dsp:sp>
     <dsp:sp modelId="{AF579611-1F25-4649-9831-825F42C8B7F0}">
       <dsp:nvSpPr>
-        <dsp:cNvPr id="6" name="矩形 5"/>
+        <dsp:cNvPr id="0" name=""/>
         <dsp:cNvSpPr/>
       </dsp:nvSpPr>
-      <dsp:spPr bwMode="white">
+      <dsp:spPr>
         <a:xfrm>
-          <a:off x="3669793" y="1395149"/>
-          <a:ext cx="856285" cy="856285"/>
+          <a:off x="3670470" y="1153021"/>
+          <a:ext cx="854929" cy="854929"/>
         </a:xfrm>
         <a:prstGeom prst="rect">
           <a:avLst/>
         </a:prstGeom>
         <a:blipFill>
-          <a:blip r:embed="rId4">
+          <a:blip xmlns:r="http://schemas.openxmlformats.org/officeDocument/2006/relationships">
             <a:extLst>
               <a:ext uri="{28A0092B-C50C-407E-A947-70E740481C1C}">
                 <a14:useLocalDpi xmlns:a14="http://schemas.microsoft.com/office/drawing/2010/main" val="0"/>
               </a:ext>
               <a:ext uri="{96DAC541-7B7A-43D3-8B79-37D633B846F1}">
-                <asvg:svgBlip xmlns:asvg="http://schemas.microsoft.com/office/drawing/2016/SVG/main" r:embed="rId5"/>
+                <asvg:svgBlip xmlns:asvg="http://schemas.microsoft.com/office/drawing/2016/SVG/main" r:embed="rId3"/>
               </a:ext>
             </a:extLst>
           </a:blip>
@@ -3776,18 +3589,18 @@
             <a:fillRect/>
           </a:stretch>
         </a:blipFill>
-        <a:ln>
+        <a:ln w="25400" cap="flat" cmpd="sng" algn="ctr">
           <a:noFill/>
+          <a:prstDash val="solid"/>
         </a:ln>
+        <a:effectLst/>
       </dsp:spPr>
       <dsp:style>
         <a:lnRef idx="2">
-          <a:schemeClr val="lt1">
-            <a:alpha val="0"/>
-          </a:schemeClr>
+          <a:scrgbClr r="0" g="0" b="0"/>
         </a:lnRef>
         <a:fillRef idx="1">
-          <a:schemeClr val="accent3"/>
+          <a:scrgbClr r="0" g="0" b="0"/>
         </a:fillRef>
         <a:effectRef idx="0">
           <a:scrgbClr r="0" g="0" b="0"/>
@@ -3796,35 +3609,32 @@
           <a:schemeClr val="lt1"/>
         </a:fontRef>
       </dsp:style>
-      <dsp:txXfrm>
-        <a:off x="3669793" y="1395149"/>
-        <a:ext cx="856285" cy="856285"/>
-      </dsp:txXfrm>
     </dsp:sp>
     <dsp:sp modelId="{152A254A-7D4A-459E-96C7-17AB5F67E0DA}">
       <dsp:nvSpPr>
-        <dsp:cNvPr id="7" name="矩形 6"/>
+        <dsp:cNvPr id="0" name=""/>
         <dsp:cNvSpPr/>
       </dsp:nvSpPr>
-      <dsp:spPr bwMode="white">
+      <dsp:spPr>
         <a:xfrm>
-          <a:off x="2874671" y="2332565"/>
-          <a:ext cx="2446529" cy="427355"/>
+          <a:off x="2876607" y="2089081"/>
+          <a:ext cx="2442656" cy="469447"/>
         </a:xfrm>
         <a:prstGeom prst="rect">
           <a:avLst/>
         </a:prstGeom>
+        <a:noFill/>
+        <a:ln>
+          <a:noFill/>
+        </a:ln>
+        <a:effectLst/>
       </dsp:spPr>
       <dsp:style>
         <a:lnRef idx="0">
-          <a:schemeClr val="dk1">
-            <a:alpha val="0"/>
-          </a:schemeClr>
+          <a:scrgbClr r="0" g="0" b="0"/>
         </a:lnRef>
         <a:fillRef idx="0">
-          <a:schemeClr val="lt1">
-            <a:alpha val="0"/>
-          </a:schemeClr>
+          <a:scrgbClr r="0" g="0" b="0"/>
         </a:fillRef>
         <a:effectRef idx="0">
           <a:scrgbClr r="0" g="0" b="0"/>
@@ -3832,38 +3642,12 @@
         <a:fontRef idx="minor"/>
       </dsp:style>
       <dsp:txBody>
-        <a:bodyPr lIns="0" tIns="0" rIns="0" bIns="0" anchor="t"/>
-        <a:lstStyle>
-          <a:lvl1pPr algn="ctr">
-            <a:defRPr sz="1400"/>
-          </a:lvl1pPr>
-          <a:lvl2pPr marL="57150" indent="-57150" algn="ctr">
-            <a:defRPr sz="1000"/>
-          </a:lvl2pPr>
-          <a:lvl3pPr marL="114300" indent="-57150" algn="ctr">
-            <a:defRPr sz="1000"/>
-          </a:lvl3pPr>
-          <a:lvl4pPr marL="171450" indent="-57150" algn="ctr">
-            <a:defRPr sz="1000"/>
-          </a:lvl4pPr>
-          <a:lvl5pPr marL="228600" indent="-57150" algn="ctr">
-            <a:defRPr sz="1000"/>
-          </a:lvl5pPr>
-          <a:lvl6pPr marL="285750" indent="-57150" algn="ctr">
-            <a:defRPr sz="1000"/>
-          </a:lvl6pPr>
-          <a:lvl7pPr marL="342900" indent="-57150" algn="ctr">
-            <a:defRPr sz="1000"/>
-          </a:lvl7pPr>
-          <a:lvl8pPr marL="400050" indent="-57150" algn="ctr">
-            <a:defRPr sz="1000"/>
-          </a:lvl8pPr>
-          <a:lvl9pPr marL="457200" indent="-57150" algn="ctr">
-            <a:defRPr sz="1000"/>
-          </a:lvl9pPr>
-        </a:lstStyle>
+        <a:bodyPr spcFirstLastPara="0" vert="horz" wrap="square" lIns="0" tIns="0" rIns="0" bIns="0" numCol="1" spcCol="1270" anchor="t" anchorCtr="0">
+          <a:noAutofit/>
+        </a:bodyPr>
+        <a:lstStyle/>
         <a:p>
-          <a:pPr lvl="0">
+          <a:pPr marL="0" lvl="0" indent="0" algn="ctr" defTabSz="622300">
             <a:lnSpc>
               <a:spcPct val="100000"/>
             </a:lnSpc>
@@ -3873,146 +3657,85 @@
             <a:spcAft>
               <a:spcPct val="35000"/>
             </a:spcAft>
+            <a:buNone/>
           </a:pPr>
           <a:r>
-            <a:rPr lang="en-US">
-              <a:solidFill>
-                <a:schemeClr val="tx1"/>
-              </a:solidFill>
-            </a:rPr>
+            <a:rPr lang="en-US" sz="1400" kern="1200"/>
             <a:t>SpringBoot</a:t>
           </a:r>
           <a:r>
-            <a:rPr lang="zh-CN">
-              <a:solidFill>
-                <a:schemeClr val="tx1"/>
-              </a:solidFill>
-            </a:rPr>
+            <a:rPr lang="zh-CN" sz="1400" kern="1200"/>
             <a:t>：简化</a:t>
           </a:r>
           <a:r>
-            <a:rPr lang="en-US">
-              <a:solidFill>
-                <a:schemeClr val="tx1"/>
-              </a:solidFill>
-            </a:rPr>
+            <a:rPr lang="en-US" sz="1400" kern="1200"/>
             <a:t>SSM</a:t>
           </a:r>
           <a:r>
-            <a:rPr lang="zh-CN">
-              <a:solidFill>
-                <a:schemeClr val="tx1"/>
-              </a:solidFill>
-            </a:rPr>
+            <a:rPr lang="zh-CN" sz="1400" kern="1200"/>
             <a:t>框架的开发</a:t>
           </a:r>
-          <a:endParaRPr lang="en-US">
-            <a:solidFill>
-              <a:schemeClr val="tx1"/>
-            </a:solidFill>
-          </a:endParaRPr>
+          <a:endParaRPr lang="en-US" sz="1400" kern="1200"/>
         </a:p>
       </dsp:txBody>
       <dsp:txXfrm>
-        <a:off x="2874671" y="2332565"/>
-        <a:ext cx="2446529" cy="427355"/>
+        <a:off x="2876607" y="2089081"/>
+        <a:ext cx="2442656" cy="469447"/>
       </dsp:txXfrm>
     </dsp:sp>
     <dsp:sp modelId="{B39D1486-23FE-4EDC-9F89-631E92854286}">
       <dsp:nvSpPr>
-        <dsp:cNvPr id="8" name="矩形 7"/>
+        <dsp:cNvPr id="0" name=""/>
         <dsp:cNvSpPr/>
       </dsp:nvSpPr>
-      <dsp:spPr bwMode="white">
+      <dsp:spPr>
         <a:xfrm>
-          <a:off x="2874671" y="2797656"/>
-          <a:ext cx="2446529" cy="0"/>
+          <a:off x="2876607" y="2596265"/>
+          <a:ext cx="2442656" cy="443518"/>
         </a:xfrm>
         <a:prstGeom prst="rect">
           <a:avLst/>
         </a:prstGeom>
+        <a:noFill/>
+        <a:ln>
+          <a:noFill/>
+        </a:ln>
+        <a:effectLst/>
       </dsp:spPr>
       <dsp:style>
         <a:lnRef idx="0">
-          <a:schemeClr val="dk1">
-            <a:alpha val="0"/>
-          </a:schemeClr>
+          <a:scrgbClr r="0" g="0" b="0"/>
         </a:lnRef>
         <a:fillRef idx="0">
-          <a:schemeClr val="lt1">
-            <a:alpha val="0"/>
-          </a:schemeClr>
+          <a:scrgbClr r="0" g="0" b="0"/>
         </a:fillRef>
         <a:effectRef idx="0">
           <a:scrgbClr r="0" g="0" b="0"/>
         </a:effectRef>
         <a:fontRef idx="minor"/>
       </dsp:style>
-      <dsp:txBody>
-        <a:bodyPr lIns="0" tIns="0" rIns="0" bIns="0" anchor="t"/>
-        <a:lstStyle>
-          <a:lvl1pPr algn="ctr">
-            <a:defRPr sz="500"/>
-          </a:lvl1pPr>
-          <a:lvl2pPr marL="57150" indent="-57150" algn="ctr">
-            <a:defRPr sz="400"/>
-          </a:lvl2pPr>
-          <a:lvl3pPr marL="114300" indent="-57150" algn="ctr">
-            <a:defRPr sz="400"/>
-          </a:lvl3pPr>
-          <a:lvl4pPr marL="171450" indent="-57150" algn="ctr">
-            <a:defRPr sz="400"/>
-          </a:lvl4pPr>
-          <a:lvl5pPr marL="228600" indent="-57150" algn="ctr">
-            <a:defRPr sz="400"/>
-          </a:lvl5pPr>
-          <a:lvl6pPr marL="285750" indent="-57150" algn="ctr">
-            <a:defRPr sz="400"/>
-          </a:lvl6pPr>
-          <a:lvl7pPr marL="342900" indent="-57150" algn="ctr">
-            <a:defRPr sz="400"/>
-          </a:lvl7pPr>
-          <a:lvl8pPr marL="400050" indent="-57150" algn="ctr">
-            <a:defRPr sz="400"/>
-          </a:lvl8pPr>
-          <a:lvl9pPr marL="457200" indent="-57150" algn="ctr">
-            <a:defRPr sz="400"/>
-          </a:lvl9pPr>
-        </a:lstStyle>
-        <a:p>
-          <a:endParaRPr>
-            <a:solidFill>
-              <a:schemeClr val="tx1"/>
-            </a:solidFill>
-          </a:endParaRPr>
-        </a:p>
-      </dsp:txBody>
-      <dsp:txXfrm>
-        <a:off x="2874671" y="2797656"/>
-        <a:ext cx="2446529" cy="0"/>
-      </dsp:txXfrm>
     </dsp:sp>
     <dsp:sp modelId="{15B3AE17-1AF3-4F52-BD6F-AA4FE5201B57}">
       <dsp:nvSpPr>
-        <dsp:cNvPr id="9" name="矩形 8"/>
+        <dsp:cNvPr id="0" name=""/>
         <dsp:cNvSpPr/>
       </dsp:nvSpPr>
-      <dsp:spPr bwMode="white">
+      <dsp:spPr>
         <a:xfrm>
-          <a:off x="6544464" y="1395149"/>
-          <a:ext cx="856285" cy="856285"/>
+          <a:off x="6540591" y="1153021"/>
+          <a:ext cx="854929" cy="854929"/>
         </a:xfrm>
         <a:prstGeom prst="rect">
           <a:avLst/>
         </a:prstGeom>
         <a:blipFill>
-          <a:blip r:embed="rId6">
+          <a:blip xmlns:r="http://schemas.openxmlformats.org/officeDocument/2006/relationships">
             <a:extLst>
               <a:ext uri="{28A0092B-C50C-407E-A947-70E740481C1C}">
                 <a14:useLocalDpi xmlns:a14="http://schemas.microsoft.com/office/drawing/2010/main" val="0"/>
               </a:ext>
               <a:ext uri="{96DAC541-7B7A-43D3-8B79-37D633B846F1}">
-                <asvg:svgBlip xmlns:asvg="http://schemas.microsoft.com/office/drawing/2016/SVG/main" r:embed="rId7"/>
+                <asvg:svgBlip xmlns:asvg="http://schemas.microsoft.com/office/drawing/2016/SVG/main" r:embed="rId4"/>
               </a:ext>
             </a:extLst>
           </a:blip>
@@ -4020,18 +3743,18 @@
             <a:fillRect/>
           </a:stretch>
         </a:blipFill>
-        <a:ln>
+        <a:ln w="25400" cap="flat" cmpd="sng" algn="ctr">
           <a:noFill/>
+          <a:prstDash val="solid"/>
         </a:ln>
+        <a:effectLst/>
       </dsp:spPr>
       <dsp:style>
         <a:lnRef idx="2">
-          <a:schemeClr val="lt1">
-            <a:alpha val="0"/>
-          </a:schemeClr>
+          <a:scrgbClr r="0" g="0" b="0"/>
         </a:lnRef>
         <a:fillRef idx="1">
-          <a:schemeClr val="accent4"/>
+          <a:scrgbClr r="0" g="0" b="0"/>
         </a:fillRef>
         <a:effectRef idx="0">
           <a:scrgbClr r="0" g="0" b="0"/>
@@ -4040,35 +3763,32 @@
           <a:schemeClr val="lt1"/>
         </a:fontRef>
       </dsp:style>
-      <dsp:txXfrm>
-        <a:off x="6544464" y="1395149"/>
-        <a:ext cx="856285" cy="856285"/>
-      </dsp:txXfrm>
     </dsp:sp>
     <dsp:sp modelId="{D67B82AC-38E7-48BE-8164-685FC650FD0F}">
       <dsp:nvSpPr>
-        <dsp:cNvPr id="10" name="矩形 9"/>
+        <dsp:cNvPr id="0" name=""/>
         <dsp:cNvSpPr/>
       </dsp:nvSpPr>
-      <dsp:spPr bwMode="white">
+      <dsp:spPr>
         <a:xfrm>
-          <a:off x="5749342" y="2332565"/>
-          <a:ext cx="2446529" cy="427355"/>
+          <a:off x="5746728" y="2089081"/>
+          <a:ext cx="2442656" cy="469447"/>
         </a:xfrm>
         <a:prstGeom prst="rect">
           <a:avLst/>
         </a:prstGeom>
+        <a:noFill/>
+        <a:ln>
+          <a:noFill/>
+        </a:ln>
+        <a:effectLst/>
       </dsp:spPr>
       <dsp:style>
         <a:lnRef idx="0">
-          <a:schemeClr val="dk1">
-            <a:alpha val="0"/>
-          </a:schemeClr>
+          <a:scrgbClr r="0" g="0" b="0"/>
         </a:lnRef>
         <a:fillRef idx="0">
-          <a:schemeClr val="lt1">
-            <a:alpha val="0"/>
-          </a:schemeClr>
+          <a:scrgbClr r="0" g="0" b="0"/>
         </a:fillRef>
         <a:effectRef idx="0">
           <a:scrgbClr r="0" g="0" b="0"/>
@@ -4076,38 +3796,12 @@
         <a:fontRef idx="minor"/>
       </dsp:style>
       <dsp:txBody>
-        <a:bodyPr lIns="0" tIns="0" rIns="0" bIns="0" anchor="t"/>
-        <a:lstStyle>
-          <a:lvl1pPr algn="ctr">
-            <a:defRPr sz="1400"/>
-          </a:lvl1pPr>
-          <a:lvl2pPr marL="57150" indent="-57150" algn="ctr">
-            <a:defRPr sz="1000"/>
-          </a:lvl2pPr>
-          <a:lvl3pPr marL="114300" indent="-57150" algn="ctr">
-            <a:defRPr sz="1000"/>
-          </a:lvl3pPr>
-          <a:lvl4pPr marL="171450" indent="-57150" algn="ctr">
-            <a:defRPr sz="1000"/>
-          </a:lvl4pPr>
-          <a:lvl5pPr marL="228600" indent="-57150" algn="ctr">
-            <a:defRPr sz="1000"/>
-          </a:lvl5pPr>
-          <a:lvl6pPr marL="285750" indent="-57150" algn="ctr">
-            <a:defRPr sz="1000"/>
-          </a:lvl6pPr>
-          <a:lvl7pPr marL="342900" indent="-57150" algn="ctr">
-            <a:defRPr sz="1000"/>
-          </a:lvl7pPr>
-          <a:lvl8pPr marL="400050" indent="-57150" algn="ctr">
-            <a:defRPr sz="1000"/>
-          </a:lvl8pPr>
-          <a:lvl9pPr marL="457200" indent="-57150" algn="ctr">
-            <a:defRPr sz="1000"/>
-          </a:lvl9pPr>
-        </a:lstStyle>
+        <a:bodyPr spcFirstLastPara="0" vert="horz" wrap="square" lIns="0" tIns="0" rIns="0" bIns="0" numCol="1" spcCol="1270" anchor="t" anchorCtr="0">
+          <a:noAutofit/>
+        </a:bodyPr>
+        <a:lstStyle/>
         <a:p>
-          <a:pPr lvl="0">
+          <a:pPr marL="0" lvl="0" indent="0" algn="ctr" defTabSz="622300">
             <a:lnSpc>
               <a:spcPct val="100000"/>
             </a:lnSpc>
@@ -4117,156 +3811,79 @@
             <a:spcAft>
               <a:spcPct val="35000"/>
             </a:spcAft>
+            <a:buNone/>
           </a:pPr>
           <a:r>
-            <a:rPr lang="en-US">
-              <a:solidFill>
-                <a:schemeClr val="tx1"/>
-              </a:solidFill>
-            </a:rPr>
+            <a:rPr lang="en-US" sz="1400" kern="1200"/>
             <a:t>Curl</a:t>
           </a:r>
           <a:r>
-            <a:rPr lang="zh-CN">
-              <a:solidFill>
-                <a:schemeClr val="tx1"/>
-              </a:solidFill>
-            </a:rPr>
+            <a:rPr lang="zh-CN" sz="1400" kern="1200"/>
             <a:t>、</a:t>
           </a:r>
           <a:r>
-            <a:rPr lang="en-US">
-              <a:solidFill>
-                <a:schemeClr val="tx1"/>
-              </a:solidFill>
-            </a:rPr>
+            <a:rPr lang="en-US" sz="1400" kern="1200"/>
             <a:t>Apifox</a:t>
           </a:r>
           <a:r>
-            <a:rPr lang="zh-CN">
-              <a:solidFill>
-                <a:schemeClr val="tx1"/>
-              </a:solidFill>
-            </a:rPr>
+            <a:rPr lang="zh-CN" sz="1400" kern="1200"/>
             <a:t> 、</a:t>
           </a:r>
           <a:r>
-            <a:rPr lang="en-US">
-              <a:solidFill>
-                <a:schemeClr val="tx1"/>
-              </a:solidFill>
-            </a:rPr>
+            <a:rPr lang="en-US" sz="1400" kern="1200"/>
             <a:t>Postman</a:t>
           </a:r>
           <a:r>
-            <a:rPr lang="zh-CN">
-              <a:solidFill>
-                <a:schemeClr val="tx1"/>
-              </a:solidFill>
-            </a:rPr>
+            <a:rPr lang="zh-CN" sz="1400" kern="1200"/>
             <a:t>、</a:t>
           </a:r>
           <a:r>
-            <a:rPr lang="en-US">
-              <a:solidFill>
-                <a:schemeClr val="tx1"/>
-              </a:solidFill>
-            </a:rPr>
+            <a:rPr lang="en-US" sz="1400" kern="1200"/>
             <a:t>Json-server</a:t>
           </a:r>
           <a:r>
-            <a:rPr lang="zh-CN">
-              <a:solidFill>
-                <a:schemeClr val="tx1"/>
-              </a:solidFill>
-            </a:rPr>
+            <a:rPr lang="zh-CN" sz="1400" kern="1200"/>
             <a:t>等工具的使用</a:t>
           </a:r>
-          <a:endParaRPr lang="en-US">
-            <a:solidFill>
-              <a:schemeClr val="tx1"/>
-            </a:solidFill>
-          </a:endParaRPr>
+          <a:endParaRPr lang="en-US" sz="1400" kern="1200"/>
         </a:p>
       </dsp:txBody>
       <dsp:txXfrm>
-        <a:off x="5749342" y="2332565"/>
-        <a:ext cx="2446529" cy="427355"/>
+        <a:off x="5746728" y="2089081"/>
+        <a:ext cx="2442656" cy="469447"/>
       </dsp:txXfrm>
     </dsp:sp>
     <dsp:sp modelId="{000B057E-25CD-4964-A877-FBC437CB93AD}">
       <dsp:nvSpPr>
-        <dsp:cNvPr id="11" name="矩形 10"/>
+        <dsp:cNvPr id="0" name=""/>
         <dsp:cNvSpPr/>
       </dsp:nvSpPr>
-      <dsp:spPr bwMode="white">
+      <dsp:spPr>
         <a:xfrm>
-          <a:off x="5749342" y="2797656"/>
-          <a:ext cx="2446529" cy="0"/>
+          <a:off x="5746728" y="2596265"/>
+          <a:ext cx="2442656" cy="443518"/>
         </a:xfrm>
         <a:prstGeom prst="rect">
           <a:avLst/>
         </a:prstGeom>
+        <a:noFill/>
+        <a:ln>
+          <a:noFill/>
+        </a:ln>
+        <a:effectLst/>
       </dsp:spPr>
       <dsp:style>
         <a:lnRef idx="0">
-          <a:schemeClr val="dk1">
-            <a:alpha val="0"/>
-          </a:schemeClr>
+          <a:scrgbClr r="0" g="0" b="0"/>
         </a:lnRef>
         <a:fillRef idx="0">
-          <a:schemeClr val="lt1">
-            <a:alpha val="0"/>
-          </a:schemeClr>
+          <a:scrgbClr r="0" g="0" b="0"/>
         </a:fillRef>
         <a:effectRef idx="0">
           <a:scrgbClr r="0" g="0" b="0"/>
         </a:effectRef>
         <a:fontRef idx="minor"/>
       </dsp:style>
-      <dsp:txBody>
-        <a:bodyPr lIns="0" tIns="0" rIns="0" bIns="0" anchor="t"/>
-        <a:lstStyle>
-          <a:lvl1pPr algn="ctr">
-            <a:defRPr sz="500"/>
-          </a:lvl1pPr>
-          <a:lvl2pPr marL="57150" indent="-57150" algn="ctr">
-            <a:defRPr sz="400"/>
-          </a:lvl2pPr>
-          <a:lvl3pPr marL="114300" indent="-57150" algn="ctr">
-            <a:defRPr sz="400"/>
-          </a:lvl3pPr>
-          <a:lvl4pPr marL="171450" indent="-57150" algn="ctr">
-            <a:defRPr sz="400"/>
-          </a:lvl4pPr>
-          <a:lvl5pPr marL="228600" indent="-57150" algn="ctr">
-            <a:defRPr sz="400"/>
-          </a:lvl5pPr>
-          <a:lvl6pPr marL="285750" indent="-57150" algn="ctr">
-            <a:defRPr sz="400"/>
-          </a:lvl6pPr>
-          <a:lvl7pPr marL="342900" indent="-57150" algn="ctr">
-            <a:defRPr sz="400"/>
-          </a:lvl7pPr>
-          <a:lvl8pPr marL="400050" indent="-57150" algn="ctr">
-            <a:defRPr sz="400"/>
-          </a:lvl8pPr>
-          <a:lvl9pPr marL="457200" indent="-57150" algn="ctr">
-            <a:defRPr sz="400"/>
-          </a:lvl9pPr>
-        </a:lstStyle>
-        <a:p>
-          <a:endParaRPr>
-            <a:solidFill>
-              <a:schemeClr val="tx1"/>
-            </a:solidFill>
-          </a:endParaRPr>
-        </a:p>
-      </dsp:txBody>
-      <dsp:txXfrm>
-        <a:off x="5749342" y="2797656"/>
-        <a:ext cx="2446529" cy="0"/>
-      </dsp:txXfrm>
     </dsp:sp>
   </dsp:spTree>
 </dsp:drawing>
@@ -4674,7 +4291,7 @@
 </file>
 
 <file path=ppt/diagrams/quickStyle1.xml><?xml version="1.0" encoding="utf-8"?>
-<dgm:styleDef xmlns:dgm="http://schemas.openxmlformats.org/drawingml/2006/diagram" xmlns:a="http://schemas.openxmlformats.org/drawingml/2006/main" uniqueId="urn:microsoft.com/office/officeart/2005/8/quickstyle/simple1">
+<dgm:styleDef xmlns:dgm="http://schemas.openxmlformats.org/drawingml/2006/diagram" xmlns:a="http://schemas.openxmlformats.org/drawingml/2006/main" uniqueId="urn:microsoft.com/office/officeart/2005/8/quickstyle/simple1#1">
   <dgm:title val=""/>
   <dgm:desc val=""/>
   <dgm:catLst>
@@ -4689,6 +4306,7 @@
       <a:camera prst="orthographicFront"/>
       <a:lightRig rig="threePt" dir="t"/>
     </dgm:scene3d>
+    <dgm:sp3d/>
     <dgm:txPr/>
     <dgm:style>
       <a:lnRef idx="2">
@@ -4708,6 +4326,7 @@
       <a:camera prst="orthographicFront"/>
       <a:lightRig rig="threePt" dir="t"/>
     </dgm:scene3d>
+    <dgm:sp3d/>
     <dgm:txPr/>
     <dgm:style>
       <a:lnRef idx="2">
@@ -4727,6 +4346,7 @@
       <a:camera prst="orthographicFront"/>
       <a:lightRig rig="threePt" dir="t"/>
     </dgm:scene3d>
+    <dgm:sp3d/>
     <dgm:txPr/>
     <dgm:style>
       <a:lnRef idx="2">
@@ -4746,6 +4366,7 @@
       <a:camera prst="orthographicFront"/>
       <a:lightRig rig="threePt" dir="t"/>
     </dgm:scene3d>
+    <dgm:sp3d/>
     <dgm:txPr/>
     <dgm:style>
       <a:lnRef idx="2">
@@ -4767,6 +4388,7 @@
       <a:camera prst="orthographicFront"/>
       <a:lightRig rig="threePt" dir="t"/>
     </dgm:scene3d>
+    <dgm:sp3d/>
     <dgm:txPr/>
     <dgm:style>
       <a:lnRef idx="2">
@@ -4788,6 +4410,7 @@
       <a:camera prst="orthographicFront"/>
       <a:lightRig rig="threePt" dir="t"/>
     </dgm:scene3d>
+    <dgm:sp3d/>
     <dgm:txPr/>
     <dgm:style>
       <a:lnRef idx="2">
@@ -4809,6 +4432,7 @@
       <a:camera prst="orthographicFront"/>
       <a:lightRig rig="threePt" dir="t"/>
     </dgm:scene3d>
+    <dgm:sp3d/>
     <dgm:txPr/>
     <dgm:style>
       <a:lnRef idx="2">
@@ -4830,6 +4454,7 @@
       <a:camera prst="orthographicFront"/>
       <a:lightRig rig="threePt" dir="t"/>
     </dgm:scene3d>
+    <dgm:sp3d/>
     <dgm:txPr/>
     <dgm:style>
       <a:lnRef idx="2">
@@ -4851,6 +4476,7 @@
       <a:camera prst="orthographicFront"/>
       <a:lightRig rig="threePt" dir="t"/>
     </dgm:scene3d>
+    <dgm:sp3d/>
     <dgm:txPr/>
     <dgm:style>
       <a:lnRef idx="2">
@@ -4872,6 +4498,7 @@
       <a:camera prst="orthographicFront"/>
       <a:lightRig rig="threePt" dir="t"/>
     </dgm:scene3d>
+    <dgm:sp3d/>
     <dgm:txPr/>
     <dgm:style>
       <a:lnRef idx="2">
@@ -4891,6 +4518,7 @@
       <a:camera prst="orthographicFront"/>
       <a:lightRig rig="threePt" dir="t"/>
     </dgm:scene3d>
+    <dgm:sp3d/>
     <dgm:txPr/>
     <dgm:style>
       <a:lnRef idx="2">
@@ -4910,6 +4538,7 @@
       <a:camera prst="orthographicFront"/>
       <a:lightRig rig="threePt" dir="t"/>
     </dgm:scene3d>
+    <dgm:sp3d/>
     <dgm:txPr/>
     <dgm:style>
       <a:lnRef idx="2">
@@ -4929,6 +4558,7 @@
       <a:camera prst="orthographicFront"/>
       <a:lightRig rig="threePt" dir="t"/>
     </dgm:scene3d>
+    <dgm:sp3d/>
     <dgm:txPr/>
     <dgm:style>
       <a:lnRef idx="0">
@@ -4948,6 +4578,7 @@
       <a:camera prst="orthographicFront"/>
       <a:lightRig rig="threePt" dir="t"/>
     </dgm:scene3d>
+    <dgm:sp3d/>
     <dgm:txPr/>
     <dgm:style>
       <a:lnRef idx="0">
@@ -4969,6 +4600,7 @@
       <a:camera prst="orthographicFront"/>
       <a:lightRig rig="threePt" dir="t"/>
     </dgm:scene3d>
+    <dgm:sp3d/>
     <dgm:txPr/>
     <dgm:style>
       <a:lnRef idx="2">
@@ -4988,6 +4620,7 @@
       <a:camera prst="orthographicFront"/>
       <a:lightRig rig="threePt" dir="t"/>
     </dgm:scene3d>
+    <dgm:sp3d/>
     <dgm:txPr/>
     <dgm:style>
       <a:lnRef idx="2">
@@ -5007,6 +4640,7 @@
       <a:camera prst="orthographicFront"/>
       <a:lightRig rig="threePt" dir="t"/>
     </dgm:scene3d>
+    <dgm:sp3d/>
     <dgm:txPr/>
     <dgm:style>
       <a:lnRef idx="0">
@@ -5026,6 +4660,7 @@
       <a:camera prst="orthographicFront"/>
       <a:lightRig rig="threePt" dir="t"/>
     </dgm:scene3d>
+    <dgm:sp3d/>
     <dgm:txPr/>
     <dgm:style>
       <a:lnRef idx="2">
@@ -5045,6 +4680,7 @@
       <a:camera prst="orthographicFront"/>
       <a:lightRig rig="threePt" dir="t"/>
     </dgm:scene3d>
+    <dgm:sp3d/>
     <dgm:txPr/>
     <dgm:style>
       <a:lnRef idx="2">
@@ -5064,6 +4700,7 @@
       <a:camera prst="orthographicFront"/>
       <a:lightRig rig="threePt" dir="t"/>
     </dgm:scene3d>
+    <dgm:sp3d/>
     <dgm:txPr/>
     <dgm:style>
       <a:lnRef idx="2">
@@ -5083,6 +4720,7 @@
       <a:camera prst="orthographicFront"/>
       <a:lightRig rig="threePt" dir="t"/>
     </dgm:scene3d>
+    <dgm:sp3d/>
     <dgm:txPr/>
     <dgm:style>
       <a:lnRef idx="2">
@@ -5102,6 +4740,7 @@
       <a:camera prst="orthographicFront"/>
       <a:lightRig rig="threePt" dir="t"/>
     </dgm:scene3d>
+    <dgm:sp3d/>
     <dgm:txPr/>
     <dgm:style>
       <a:lnRef idx="2">
@@ -5121,6 +4760,7 @@
       <a:camera prst="orthographicFront"/>
       <a:lightRig rig="threePt" dir="t"/>
     </dgm:scene3d>
+    <dgm:sp3d/>
     <dgm:txPr/>
     <dgm:style>
       <a:lnRef idx="2">
@@ -5140,6 +4780,7 @@
       <a:camera prst="orthographicFront"/>
       <a:lightRig rig="threePt" dir="t"/>
     </dgm:scene3d>
+    <dgm:sp3d/>
     <dgm:txPr/>
     <dgm:style>
       <a:lnRef idx="2">
@@ -5159,6 +4800,7 @@
       <a:camera prst="orthographicFront"/>
       <a:lightRig rig="threePt" dir="t"/>
     </dgm:scene3d>
+    <dgm:sp3d/>
     <dgm:txPr/>
     <dgm:style>
       <a:lnRef idx="2">
@@ -5178,6 +4820,7 @@
       <a:camera prst="orthographicFront"/>
       <a:lightRig rig="threePt" dir="t"/>
     </dgm:scene3d>
+    <dgm:sp3d/>
     <dgm:txPr/>
     <dgm:style>
       <a:lnRef idx="0">
@@ -5199,6 +4842,7 @@
       <a:camera prst="orthographicFront"/>
       <a:lightRig rig="threePt" dir="t"/>
     </dgm:scene3d>
+    <dgm:sp3d/>
     <dgm:txPr/>
     <dgm:style>
       <a:lnRef idx="2">
@@ -5220,6 +4864,7 @@
       <a:camera prst="orthographicFront"/>
       <a:lightRig rig="threePt" dir="t"/>
     </dgm:scene3d>
+    <dgm:sp3d/>
     <dgm:txPr/>
     <dgm:style>
       <a:lnRef idx="2">
@@ -5241,6 +4886,7 @@
       <a:camera prst="orthographicFront"/>
       <a:lightRig rig="threePt" dir="t"/>
     </dgm:scene3d>
+    <dgm:sp3d/>
     <dgm:txPr/>
     <dgm:style>
       <a:lnRef idx="2">
@@ -5262,6 +4908,7 @@
       <a:camera prst="orthographicFront"/>
       <a:lightRig rig="threePt" dir="t"/>
     </dgm:scene3d>
+    <dgm:sp3d/>
     <dgm:txPr/>
     <dgm:style>
       <a:lnRef idx="2">
@@ -5283,6 +4930,7 @@
       <a:camera prst="orthographicFront"/>
       <a:lightRig rig="threePt" dir="t"/>
     </dgm:scene3d>
+    <dgm:sp3d/>
     <dgm:txPr/>
     <dgm:style>
       <a:lnRef idx="2">
@@ -5304,6 +4952,7 @@
       <a:camera prst="orthographicFront"/>
       <a:lightRig rig="threePt" dir="t"/>
     </dgm:scene3d>
+    <dgm:sp3d/>
     <dgm:txPr/>
     <dgm:style>
       <a:lnRef idx="2">
@@ -5325,6 +4974,7 @@
       <a:camera prst="orthographicFront"/>
       <a:lightRig rig="threePt" dir="t"/>
     </dgm:scene3d>
+    <dgm:sp3d/>
     <dgm:txPr/>
     <dgm:style>
       <a:lnRef idx="2">
@@ -5344,6 +4994,7 @@
       <a:camera prst="orthographicFront"/>
       <a:lightRig rig="threePt" dir="t"/>
     </dgm:scene3d>
+    <dgm:sp3d/>
     <dgm:txPr/>
     <dgm:style>
       <a:lnRef idx="2">
@@ -5363,6 +5014,7 @@
       <a:camera prst="orthographicFront"/>
       <a:lightRig rig="threePt" dir="t"/>
     </dgm:scene3d>
+    <dgm:sp3d/>
     <dgm:txPr/>
     <dgm:style>
       <a:lnRef idx="2">
@@ -5382,6 +5034,7 @@
       <a:camera prst="orthographicFront"/>
       <a:lightRig rig="threePt" dir="t"/>
     </dgm:scene3d>
+    <dgm:sp3d/>
     <dgm:txPr/>
     <dgm:style>
       <a:lnRef idx="2">
@@ -5401,6 +5054,7 @@
       <a:camera prst="orthographicFront"/>
       <a:lightRig rig="threePt" dir="t"/>
     </dgm:scene3d>
+    <dgm:sp3d/>
     <dgm:txPr/>
     <dgm:style>
       <a:lnRef idx="2">
@@ -5422,6 +5076,7 @@
       <a:camera prst="orthographicFront"/>
       <a:lightRig rig="threePt" dir="t"/>
     </dgm:scene3d>
+    <dgm:sp3d/>
     <dgm:txPr/>
     <dgm:style>
       <a:lnRef idx="2">
@@ -5443,6 +5098,7 @@
       <a:camera prst="orthographicFront"/>
       <a:lightRig rig="threePt" dir="t"/>
     </dgm:scene3d>
+    <dgm:sp3d/>
     <dgm:txPr/>
     <dgm:style>
       <a:lnRef idx="2">
@@ -5464,6 +5120,7 @@
       <a:camera prst="orthographicFront"/>
       <a:lightRig rig="threePt" dir="t"/>
     </dgm:scene3d>
+    <dgm:sp3d/>
     <dgm:txPr/>
     <dgm:style>
       <a:lnRef idx="2">
@@ -5485,6 +5142,7 @@
       <a:camera prst="orthographicFront"/>
       <a:lightRig rig="threePt" dir="t"/>
     </dgm:scene3d>
+    <dgm:sp3d/>
     <dgm:txPr/>
     <dgm:style>
       <a:lnRef idx="0">
@@ -5504,6 +5162,7 @@
       <a:camera prst="orthographicFront"/>
       <a:lightRig rig="threePt" dir="t"/>
     </dgm:scene3d>
+    <dgm:sp3d/>
     <dgm:txPr/>
     <dgm:style>
       <a:lnRef idx="1">
@@ -5523,6 +5182,7 @@
       <a:camera prst="orthographicFront"/>
       <a:lightRig rig="threePt" dir="t"/>
     </dgm:scene3d>
+    <dgm:sp3d/>
     <dgm:txPr/>
     <dgm:style>
       <a:lnRef idx="0">
@@ -5544,6 +5204,7 @@
       <a:camera prst="orthographicFront"/>
       <a:lightRig rig="threePt" dir="t"/>
     </dgm:scene3d>
+    <dgm:sp3d/>
     <dgm:txPr/>
     <dgm:style>
       <a:lnRef idx="2">
@@ -5563,6 +5224,7 @@
       <a:camera prst="orthographicFront"/>
       <a:lightRig rig="threePt" dir="t"/>
     </dgm:scene3d>
+    <dgm:sp3d/>
     <dgm:txPr/>
     <dgm:style>
       <a:lnRef idx="2">
@@ -5582,6 +5244,7 @@
       <a:camera prst="orthographicFront"/>
       <a:lightRig rig="threePt" dir="t"/>
     </dgm:scene3d>
+    <dgm:sp3d/>
     <dgm:txPr/>
     <dgm:style>
       <a:lnRef idx="2">
@@ -5601,6 +5264,7 @@
       <a:camera prst="orthographicFront"/>
       <a:lightRig rig="threePt" dir="t"/>
     </dgm:scene3d>
+    <dgm:sp3d/>
     <dgm:txPr/>
     <dgm:style>
       <a:lnRef idx="1">
@@ -5620,6 +5284,7 @@
       <a:camera prst="orthographicFront"/>
       <a:lightRig rig="threePt" dir="t"/>
     </dgm:scene3d>
+    <dgm:sp3d/>
     <dgm:txPr/>
     <dgm:style>
       <a:lnRef idx="0">
@@ -5639,6 +5304,7 @@
       <a:camera prst="orthographicFront"/>
       <a:lightRig rig="threePt" dir="t"/>
     </dgm:scene3d>
+    <dgm:sp3d/>
     <dgm:txPr/>
     <dgm:style>
       <a:lnRef idx="2">
@@ -5659,7 +5325,7 @@
 </file>
 
 <file path=ppt/diagrams/quickStyle2.xml><?xml version="1.0" encoding="utf-8"?>
-<dgm:styleDef xmlns:dgm="http://schemas.openxmlformats.org/drawingml/2006/diagram" xmlns:a="http://schemas.openxmlformats.org/drawingml/2006/main" uniqueId="urn:microsoft.com/office/officeart/2005/8/quickstyle/simple1">
+<dgm:styleDef xmlns:dgm="http://schemas.openxmlformats.org/drawingml/2006/diagram" xmlns:a="http://schemas.openxmlformats.org/drawingml/2006/main" uniqueId="urn:microsoft.com/office/officeart/2005/8/quickstyle/simple1#2">
   <dgm:title val=""/>
   <dgm:desc val=""/>
   <dgm:catLst>
@@ -5674,6 +5340,7 @@
       <a:camera prst="orthographicFront"/>
       <a:lightRig rig="threePt" dir="t"/>
     </dgm:scene3d>
+    <dgm:sp3d/>
     <dgm:txPr/>
     <dgm:style>
       <a:lnRef idx="2">
@@ -5693,6 +5360,7 @@
       <a:camera prst="orthographicFront"/>
       <a:lightRig rig="threePt" dir="t"/>
     </dgm:scene3d>
+    <dgm:sp3d/>
     <dgm:txPr/>
     <dgm:style>
       <a:lnRef idx="2">
@@ -5712,6 +5380,7 @@
       <a:camera prst="orthographicFront"/>
       <a:lightRig rig="threePt" dir="t"/>
     </dgm:scene3d>
+    <dgm:sp3d/>
     <dgm:txPr/>
     <dgm:style>
       <a:lnRef idx="2">
@@ -5731,6 +5400,7 @@
       <a:camera prst="orthographicFront"/>
       <a:lightRig rig="threePt" dir="t"/>
     </dgm:scene3d>
+    <dgm:sp3d/>
     <dgm:txPr/>
     <dgm:style>
       <a:lnRef idx="2">
@@ -5752,6 +5422,7 @@
       <a:camera prst="orthographicFront"/>
       <a:lightRig rig="threePt" dir="t"/>
     </dgm:scene3d>
+    <dgm:sp3d/>
     <dgm:txPr/>
     <dgm:style>
       <a:lnRef idx="2">
@@ -5773,6 +5444,7 @@
       <a:camera prst="orthographicFront"/>
       <a:lightRig rig="threePt" dir="t"/>
     </dgm:scene3d>
+    <dgm:sp3d/>
     <dgm:txPr/>
     <dgm:style>
       <a:lnRef idx="2">
@@ -5794,6 +5466,7 @@
       <a:camera prst="orthographicFront"/>
       <a:lightRig rig="threePt" dir="t"/>
     </dgm:scene3d>
+    <dgm:sp3d/>
     <dgm:txPr/>
     <dgm:style>
       <a:lnRef idx="2">
@@ -5815,6 +5488,7 @@
       <a:camera prst="orthographicFront"/>
       <a:lightRig rig="threePt" dir="t"/>
     </dgm:scene3d>
+    <dgm:sp3d/>
     <dgm:txPr/>
     <dgm:style>
       <a:lnRef idx="2">
@@ -5836,6 +5510,7 @@
       <a:camera prst="orthographicFront"/>
       <a:lightRig rig="threePt" dir="t"/>
     </dgm:scene3d>
+    <dgm:sp3d/>
     <dgm:txPr/>
     <dgm:style>
       <a:lnRef idx="2">
@@ -5857,6 +5532,7 @@
       <a:camera prst="orthographicFront"/>
       <a:lightRig rig="threePt" dir="t"/>
     </dgm:scene3d>
+    <dgm:sp3d/>
     <dgm:txPr/>
     <dgm:style>
       <a:lnRef idx="2">
@@ -5876,6 +5552,7 @@
       <a:camera prst="orthographicFront"/>
       <a:lightRig rig="threePt" dir="t"/>
     </dgm:scene3d>
+    <dgm:sp3d/>
     <dgm:txPr/>
     <dgm:style>
       <a:lnRef idx="2">
@@ -5895,6 +5572,7 @@
       <a:camera prst="orthographicFront"/>
       <a:lightRig rig="threePt" dir="t"/>
     </dgm:scene3d>
+    <dgm:sp3d/>
     <dgm:txPr/>
     <dgm:style>
       <a:lnRef idx="2">
@@ -5914,6 +5592,7 @@
       <a:camera prst="orthographicFront"/>
       <a:lightRig rig="threePt" dir="t"/>
     </dgm:scene3d>
+    <dgm:sp3d/>
     <dgm:txPr/>
     <dgm:style>
       <a:lnRef idx="0">
@@ -5933,6 +5612,7 @@
       <a:camera prst="orthographicFront"/>
       <a:lightRig rig="threePt" dir="t"/>
     </dgm:scene3d>
+    <dgm:sp3d/>
     <dgm:txPr/>
     <dgm:style>
       <a:lnRef idx="0">
@@ -5954,6 +5634,7 @@
       <a:camera prst="orthographicFront"/>
       <a:lightRig rig="threePt" dir="t"/>
     </dgm:scene3d>
+    <dgm:sp3d/>
     <dgm:txPr/>
     <dgm:style>
       <a:lnRef idx="2">
@@ -5973,6 +5654,7 @@
       <a:camera prst="orthographicFront"/>
       <a:lightRig rig="threePt" dir="t"/>
     </dgm:scene3d>
+    <dgm:sp3d/>
     <dgm:txPr/>
     <dgm:style>
       <a:lnRef idx="2">
@@ -5992,6 +5674,7 @@
       <a:camera prst="orthographicFront"/>
       <a:lightRig rig="threePt" dir="t"/>
     </dgm:scene3d>
+    <dgm:sp3d/>
     <dgm:txPr/>
     <dgm:style>
       <a:lnRef idx="0">
@@ -6011,6 +5694,7 @@
       <a:camera prst="orthographicFront"/>
       <a:lightRig rig="threePt" dir="t"/>
     </dgm:scene3d>
+    <dgm:sp3d/>
     <dgm:txPr/>
     <dgm:style>
       <a:lnRef idx="2">
@@ -6030,6 +5714,7 @@
       <a:camera prst="orthographicFront"/>
       <a:lightRig rig="threePt" dir="t"/>
     </dgm:scene3d>
+    <dgm:sp3d/>
     <dgm:txPr/>
     <dgm:style>
       <a:lnRef idx="2">
@@ -6049,6 +5734,7 @@
       <a:camera prst="orthographicFront"/>
       <a:lightRig rig="threePt" dir="t"/>
     </dgm:scene3d>
+    <dgm:sp3d/>
     <dgm:txPr/>
     <dgm:style>
       <a:lnRef idx="2">
@@ -6068,6 +5754,7 @@
       <a:camera prst="orthographicFront"/>
       <a:lightRig rig="threePt" dir="t"/>
     </dgm:scene3d>
+    <dgm:sp3d/>
     <dgm:txPr/>
     <dgm:style>
       <a:lnRef idx="2">
@@ -6087,6 +5774,7 @@
       <a:camera prst="orthographicFront"/>
       <a:lightRig rig="threePt" dir="t"/>
     </dgm:scene3d>
+    <dgm:sp3d/>
     <dgm:txPr/>
     <dgm:style>
       <a:lnRef idx="2">
@@ -6106,6 +5794,7 @@
       <a:camera prst="orthographicFront"/>
       <a:lightRig rig="threePt" dir="t"/>
     </dgm:scene3d>
+    <dgm:sp3d/>
     <dgm:txPr/>
     <dgm:style>
       <a:lnRef idx="2">
@@ -6125,6 +5814,7 @@
       <a:camera prst="orthographicFront"/>
       <a:lightRig rig="threePt" dir="t"/>
     </dgm:scene3d>
+    <dgm:sp3d/>
     <dgm:txPr/>
     <dgm:style>
       <a:lnRef idx="2">
@@ -6144,6 +5834,7 @@
       <a:camera prst="orthographicFront"/>
       <a:lightRig rig="threePt" dir="t"/>
     </dgm:scene3d>
+    <dgm:sp3d/>
     <dgm:txPr/>
     <dgm:style>
       <a:lnRef idx="2">
@@ -6163,6 +5854,7 @@
       <a:camera prst="orthographicFront"/>
       <a:lightRig rig="threePt" dir="t"/>
     </dgm:scene3d>
+    <dgm:sp3d/>
     <dgm:txPr/>
     <dgm:style>
       <a:lnRef idx="0">
@@ -6184,6 +5876,7 @@
       <a:camera prst="orthographicFront"/>
       <a:lightRig rig="threePt" dir="t"/>
     </dgm:scene3d>
+    <dgm:sp3d/>
     <dgm:txPr/>
     <dgm:style>
       <a:lnRef idx="2">
@@ -6205,6 +5898,7 @@
       <a:camera prst="orthographicFront"/>
       <a:lightRig rig="threePt" dir="t"/>
     </dgm:scene3d>
+    <dgm:sp3d/>
     <dgm:txPr/>
     <dgm:style>
       <a:lnRef idx="2">
@@ -6226,6 +5920,7 @@
       <a:camera prst="orthographicFront"/>
       <a:lightRig rig="threePt" dir="t"/>
     </dgm:scene3d>
+    <dgm:sp3d/>
     <dgm:txPr/>
     <dgm:style>
       <a:lnRef idx="2">
@@ -6247,6 +5942,7 @@
       <a:camera prst="orthographicFront"/>
       <a:lightRig rig="threePt" dir="t"/>
     </dgm:scene3d>
+    <dgm:sp3d/>
     <dgm:txPr/>
     <dgm:style>
       <a:lnRef idx="2">
@@ -6268,6 +5964,7 @@
       <a:camera prst="orthographicFront"/>
       <a:lightRig rig="threePt" dir="t"/>
     </dgm:scene3d>
+    <dgm:sp3d/>
     <dgm:txPr/>
     <dgm:style>
       <a:lnRef idx="2">
@@ -6289,6 +5986,7 @@
       <a:camera prst="orthographicFront"/>
       <a:lightRig rig="threePt" dir="t"/>
     </dgm:scene3d>
+    <dgm:sp3d/>
     <dgm:txPr/>
     <dgm:style>
       <a:lnRef idx="2">
@@ -6310,6 +6008,7 @@
       <a:camera prst="orthographicFront"/>
       <a:lightRig rig="threePt" dir="t"/>
     </dgm:scene3d>
+    <dgm:sp3d/>
     <dgm:txPr/>
     <dgm:style>
       <a:lnRef idx="2">
@@ -6329,6 +6028,7 @@
       <a:camera prst="orthographicFront"/>
       <a:lightRig rig="threePt" dir="t"/>
     </dgm:scene3d>
+    <dgm:sp3d/>
     <dgm:txPr/>
     <dgm:style>
       <a:lnRef idx="2">
@@ -6348,6 +6048,7 @@
       <a:camera prst="orthographicFront"/>
       <a:lightRig rig="threePt" dir="t"/>
     </dgm:scene3d>
+    <dgm:sp3d/>
     <dgm:txPr/>
     <dgm:style>
       <a:lnRef idx="2">
@@ -6367,6 +6068,7 @@
       <a:camera prst="orthographicFront"/>
       <a:lightRig rig="threePt" dir="t"/>
     </dgm:scene3d>
+    <dgm:sp3d/>
     <dgm:txPr/>
     <dgm:style>
       <a:lnRef idx="2">
@@ -6386,6 +6088,7 @@
       <a:camera prst="orthographicFront"/>
       <a:lightRig rig="threePt" dir="t"/>
     </dgm:scene3d>
+    <dgm:sp3d/>
     <dgm:txPr/>
     <dgm:style>
       <a:lnRef idx="2">
@@ -6407,6 +6110,7 @@
       <a:camera prst="orthographicFront"/>
       <a:lightRig rig="threePt" dir="t"/>
     </dgm:scene3d>
+    <dgm:sp3d/>
     <dgm:txPr/>
     <dgm:style>
       <a:lnRef idx="2">
@@ -6428,6 +6132,7 @@
       <a:camera prst="orthographicFront"/>
       <a:lightRig rig="threePt" dir="t"/>
     </dgm:scene3d>
+    <dgm:sp3d/>
     <dgm:txPr/>
     <dgm:style>
       <a:lnRef idx="2">
@@ -6449,6 +6154,7 @@
       <a:camera prst="orthographicFront"/>
       <a:lightRig rig="threePt" dir="t"/>
     </dgm:scene3d>
+    <dgm:sp3d/>
     <dgm:txPr/>
     <dgm:style>
       <a:lnRef idx="2">
@@ -6470,6 +6176,7 @@
       <a:camera prst="orthographicFront"/>
       <a:lightRig rig="threePt" dir="t"/>
     </dgm:scene3d>
+    <dgm:sp3d/>
     <dgm:txPr/>
     <dgm:style>
       <a:lnRef idx="0">
@@ -6489,6 +6196,7 @@
       <a:camera prst="orthographicFront"/>
       <a:lightRig rig="threePt" dir="t"/>
     </dgm:scene3d>
+    <dgm:sp3d/>
     <dgm:txPr/>
     <dgm:style>
       <a:lnRef idx="1">
@@ -6508,6 +6216,7 @@
       <a:camera prst="orthographicFront"/>
       <a:lightRig rig="threePt" dir="t"/>
     </dgm:scene3d>
+    <dgm:sp3d/>
     <dgm:txPr/>
     <dgm:style>
       <a:lnRef idx="0">
@@ -6529,6 +6238,7 @@
       <a:camera prst="orthographicFront"/>
       <a:lightRig rig="threePt" dir="t"/>
     </dgm:scene3d>
+    <dgm:sp3d/>
     <dgm:txPr/>
     <dgm:style>
       <a:lnRef idx="2">
@@ -6548,6 +6258,7 @@
       <a:camera prst="orthographicFront"/>
       <a:lightRig rig="threePt" dir="t"/>
     </dgm:scene3d>
+    <dgm:sp3d/>
     <dgm:txPr/>
     <dgm:style>
       <a:lnRef idx="2">
@@ -6567,6 +6278,7 @@
       <a:camera prst="orthographicFront"/>
       <a:lightRig rig="threePt" dir="t"/>
     </dgm:scene3d>
+    <dgm:sp3d/>
     <dgm:txPr/>
     <dgm:style>
       <a:lnRef idx="2">
@@ -6586,6 +6298,7 @@
       <a:camera prst="orthographicFront"/>
       <a:lightRig rig="threePt" dir="t"/>
     </dgm:scene3d>
+    <dgm:sp3d/>
     <dgm:txPr/>
     <dgm:style>
       <a:lnRef idx="1">
@@ -6605,6 +6318,7 @@
       <a:camera prst="orthographicFront"/>
       <a:lightRig rig="threePt" dir="t"/>
     </dgm:scene3d>
+    <dgm:sp3d/>
     <dgm:txPr/>
     <dgm:style>
       <a:lnRef idx="0">
@@ -6624,6 +6338,7 @@
       <a:camera prst="orthographicFront"/>
       <a:lightRig rig="threePt" dir="t"/>
     </dgm:scene3d>
+    <dgm:sp3d/>
     <dgm:txPr/>
     <dgm:style>
       <a:lnRef idx="2">
@@ -6725,6 +6440,7 @@
           <a:p>
             <a:fld id="{42F6D5A3-465E-E946-B67B-A7DA11CB92D8}" type="datetimeFigureOut">
               <a:rPr lang="en-US" smtClean="0"/>
+              <a:t>4/22/26</a:t>
             </a:fld>
             <a:endParaRPr lang="en-US"/>
           </a:p>
@@ -6791,7 +6507,6 @@
               <a:rPr lang="en-US"/>
               <a:t>Click to edit Master text styles</a:t>
             </a:r>
-            <a:endParaRPr lang="en-US"/>
           </a:p>
           <a:p>
             <a:pPr lvl="1"/>
@@ -6799,7 +6514,6 @@
               <a:rPr lang="en-US"/>
               <a:t>Second level</a:t>
             </a:r>
-            <a:endParaRPr lang="en-US"/>
           </a:p>
           <a:p>
             <a:pPr lvl="2"/>
@@ -6807,7 +6521,6 @@
               <a:rPr lang="en-US"/>
               <a:t>Third level</a:t>
             </a:r>
-            <a:endParaRPr lang="en-US"/>
           </a:p>
           <a:p>
             <a:pPr lvl="3"/>
@@ -6815,7 +6528,6 @@
               <a:rPr lang="en-US"/>
               <a:t>Fourth level</a:t>
             </a:r>
-            <a:endParaRPr lang="en-US"/>
           </a:p>
           <a:p>
             <a:pPr lvl="4"/>
@@ -6823,7 +6535,6 @@
               <a:rPr lang="en-US"/>
               <a:t>Fifth level</a:t>
             </a:r>
-            <a:endParaRPr lang="en-US"/>
           </a:p>
         </p:txBody>
       </p:sp>
@@ -6887,6 +6598,7 @@
           <a:p>
             <a:fld id="{321307BC-D318-DE4B-8CA0-D80BADC0112E}" type="slidenum">
               <a:rPr lang="en-US" smtClean="0"/>
+              <a:t>‹#›</a:t>
             </a:fld>
             <a:endParaRPr lang="en-US"/>
           </a:p>
@@ -7055,6 +6767,7 @@
           <a:p>
             <a:fld id="{321307BC-D318-DE4B-8CA0-D80BADC0112E}" type="slidenum">
               <a:rPr lang="en-US" smtClean="0"/>
+              <a:t>2</a:t>
             </a:fld>
             <a:endParaRPr lang="en-US"/>
           </a:p>
@@ -7132,7 +6845,6 @@
               <a:rPr lang="en-US" dirty="0"/>
               <a:t>dispatchServlet，handlermapping，controller，modelAndView，ViewResolver</a:t>
             </a:r>
-            <a:endParaRPr lang="en-US" dirty="0"/>
           </a:p>
           <a:p>
             <a:r>
@@ -7143,7 +6855,6 @@
               <a:rPr lang="zh-CN" altLang="en-US" dirty="0"/>
               <a:t>，分为三个阶段：初始化，匹配，执行</a:t>
             </a:r>
-            <a:endParaRPr lang="zh-CN" altLang="en-US" dirty="0"/>
           </a:p>
           <a:p>
             <a:r>
@@ -7178,7 +6889,6 @@
               <a:rPr lang="zh-CN" altLang="en-US" dirty="0"/>
               <a:t>等）</a:t>
             </a:r>
-            <a:endParaRPr lang="zh-CN" altLang="en-US" dirty="0"/>
           </a:p>
           <a:p>
             <a:r>
@@ -7225,7 +6935,6 @@
               <a:rPr lang="en-US" dirty="0"/>
               <a:t>refresh</a:t>
             </a:r>
-            <a:endParaRPr lang="en-US" dirty="0"/>
           </a:p>
           <a:p>
             <a:r>
@@ -7252,7 +6961,6 @@
               <a:rPr lang="zh-CN" altLang="en-US" dirty="0"/>
               <a:t>容器中类的副本</a:t>
             </a:r>
-            <a:endParaRPr lang="zh-CN" altLang="en-US" dirty="0"/>
           </a:p>
           <a:p>
             <a:r>
@@ -7271,7 +6979,6 @@
               <a:rPr lang="zh-CN" altLang="en-US" dirty="0"/>
               <a:t>容器中的同种类通常有多个</a:t>
             </a:r>
-            <a:endParaRPr lang="zh-CN" altLang="en-US" dirty="0"/>
           </a:p>
           <a:p>
             <a:r>
@@ -7298,7 +7005,6 @@
               <a:rPr lang="zh-CN" altLang="en-US" dirty="0"/>
               <a:t>对象。</a:t>
             </a:r>
-            <a:endParaRPr lang="zh-CN" altLang="en-US" dirty="0"/>
           </a:p>
           <a:p>
             <a:r>
@@ -7329,7 +7035,6 @@
               <a:rPr lang="en-US" dirty="0"/>
               <a:t>method</a:t>
             </a:r>
-            <a:endParaRPr lang="en-US" dirty="0"/>
           </a:p>
           <a:p>
             <a:r>
@@ -7388,7 +7093,6 @@
               <a:rPr lang="zh-CN" altLang="en-US" dirty="0"/>
               <a:t>对象</a:t>
             </a:r>
-            <a:endParaRPr lang="zh-CN" altLang="en-US" dirty="0"/>
           </a:p>
           <a:p>
             <a:r>
@@ -7439,7 +7143,6 @@
               <a:rPr lang="zh-CN" altLang="en-US" dirty="0"/>
               <a:t>容器中）</a:t>
             </a:r>
-            <a:endParaRPr lang="zh-CN" altLang="en-US" dirty="0"/>
           </a:p>
           <a:p>
             <a:r>
@@ -7478,7 +7181,6 @@
               <a:rPr lang="zh-CN" altLang="en-US" dirty="0"/>
               <a:t>相匹配。</a:t>
             </a:r>
-            <a:endParaRPr lang="zh-CN" altLang="en-US" dirty="0"/>
           </a:p>
           <a:p>
             <a:r>
@@ -7513,7 +7215,6 @@
               <a:rPr lang="zh-CN" altLang="en-US" dirty="0"/>
               <a:t>的方法）</a:t>
             </a:r>
-            <a:endParaRPr lang="zh-CN" altLang="en-US" dirty="0"/>
           </a:p>
           <a:p>
             <a:r>
@@ -7540,7 +7241,6 @@
               <a:rPr lang="zh-CN" altLang="en-US" dirty="0"/>
               <a:t>方法</a:t>
             </a:r>
-            <a:endParaRPr lang="zh-CN" altLang="en-US" dirty="0"/>
           </a:p>
           <a:p>
             <a:r>
@@ -7559,7 +7259,6 @@
               <a:rPr lang="zh-CN" altLang="en-US" dirty="0"/>
               <a:t>执行没有异常则：如下</a:t>
             </a:r>
-            <a:endParaRPr lang="zh-CN" altLang="en-US" dirty="0"/>
           </a:p>
           <a:p>
             <a:r>
@@ -7613,7 +7312,6 @@
               <a:rPr lang="zh-CN" altLang="en-US" dirty="0"/>
               <a:t>相反的拦截器触发次序）</a:t>
             </a:r>
-            <a:endParaRPr lang="zh-CN" altLang="en-US" dirty="0"/>
           </a:p>
           <a:p>
             <a:r>
@@ -7656,7 +7354,6 @@
               <a:rPr lang="en-US" dirty="0"/>
               <a:t>）</a:t>
             </a:r>
-            <a:endParaRPr lang="en-US" dirty="0"/>
           </a:p>
           <a:p>
             <a:r>
@@ -7675,7 +7372,6 @@
               <a:rPr lang="zh-CN" altLang="en-US" dirty="0"/>
               <a:t>执行有异常则：如下</a:t>
             </a:r>
-            <a:endParaRPr lang="zh-CN" altLang="en-US" dirty="0"/>
           </a:p>
           <a:p>
             <a:r>
@@ -7698,7 +7394,6 @@
               <a:rPr lang="en-US" dirty="0"/>
               <a:t>exception</a:t>
             </a:r>
-            <a:endParaRPr lang="en-US" dirty="0"/>
           </a:p>
           <a:p>
             <a:r>
@@ -7733,7 +7428,6 @@
               <a:rPr lang="zh-CN" altLang="en-US" dirty="0"/>
               <a:t>处理</a:t>
             </a:r>
-            <a:endParaRPr lang="zh-CN" altLang="en-US" dirty="0"/>
           </a:p>
           <a:p>
             <a:r>
@@ -7756,7 +7450,6 @@
               <a:rPr lang="zh-CN" altLang="en-US" dirty="0"/>
               <a:t>反序）</a:t>
             </a:r>
-            <a:endParaRPr lang="zh-CN" altLang="en-US" dirty="0"/>
           </a:p>
           <a:p>
             <a:endParaRPr lang="en-US" dirty="0"/>
@@ -7780,6 +7473,7 @@
           <a:p>
             <a:fld id="{321307BC-D318-DE4B-8CA0-D80BADC0112E}" type="slidenum">
               <a:rPr lang="en-US" smtClean="0"/>
+              <a:t>5</a:t>
             </a:fld>
             <a:endParaRPr lang="en-US"/>
           </a:p>
@@ -7865,6 +7559,7 @@
           <a:p>
             <a:fld id="{321307BC-D318-DE4B-8CA0-D80BADC0112E}" type="slidenum">
               <a:rPr lang="en-US" smtClean="0"/>
+              <a:t>13</a:t>
             </a:fld>
             <a:endParaRPr lang="en-US"/>
           </a:p>
@@ -7919,7 +7614,6 @@
               <a:rPr lang="en-US"/>
               <a:t>Click to edit Master title style</a:t>
             </a:r>
-            <a:endParaRPr lang="en-US"/>
           </a:p>
         </p:txBody>
       </p:sp>
@@ -8038,7 +7732,6 @@
               <a:rPr lang="en-US"/>
               <a:t>Click to edit Master subtitle style</a:t>
             </a:r>
-            <a:endParaRPr lang="en-US"/>
           </a:p>
         </p:txBody>
       </p:sp>
@@ -8059,6 +7752,7 @@
           <a:p>
             <a:fld id="{0897BCBE-A2DD-2248-8676-657FEEB74689}" type="datetimeFigureOut">
               <a:rPr lang="en-US" smtClean="0"/>
+              <a:t>4/22/26</a:t>
             </a:fld>
             <a:endParaRPr lang="en-US"/>
           </a:p>
@@ -8100,6 +7794,7 @@
           <a:p>
             <a:fld id="{258ECF37-3CC2-C74D-A5F5-BBEAD8F9A4D4}" type="slidenum">
               <a:rPr lang="en-US" smtClean="0"/>
+              <a:t>‹#›</a:t>
             </a:fld>
             <a:endParaRPr lang="en-US"/>
           </a:p>
@@ -8149,7 +7844,6 @@
               <a:rPr lang="en-US"/>
               <a:t>Click to edit Master title style</a:t>
             </a:r>
-            <a:endParaRPr lang="en-US"/>
           </a:p>
         </p:txBody>
       </p:sp>
@@ -8173,7 +7867,6 @@
               <a:rPr lang="en-US"/>
               <a:t>Click to edit Master text styles</a:t>
             </a:r>
-            <a:endParaRPr lang="en-US"/>
           </a:p>
           <a:p>
             <a:pPr lvl="1"/>
@@ -8181,7 +7874,6 @@
               <a:rPr lang="en-US"/>
               <a:t>Second level</a:t>
             </a:r>
-            <a:endParaRPr lang="en-US"/>
           </a:p>
           <a:p>
             <a:pPr lvl="2"/>
@@ -8189,7 +7881,6 @@
               <a:rPr lang="en-US"/>
               <a:t>Third level</a:t>
             </a:r>
-            <a:endParaRPr lang="en-US"/>
           </a:p>
           <a:p>
             <a:pPr lvl="3"/>
@@ -8197,7 +7888,6 @@
               <a:rPr lang="en-US"/>
               <a:t>Fourth level</a:t>
             </a:r>
-            <a:endParaRPr lang="en-US"/>
           </a:p>
           <a:p>
             <a:pPr lvl="4"/>
@@ -8205,7 +7895,6 @@
               <a:rPr lang="en-US"/>
               <a:t>Fifth level</a:t>
             </a:r>
-            <a:endParaRPr lang="en-US"/>
           </a:p>
         </p:txBody>
       </p:sp>
@@ -8226,6 +7915,7 @@
           <a:p>
             <a:fld id="{0897BCBE-A2DD-2248-8676-657FEEB74689}" type="datetimeFigureOut">
               <a:rPr lang="en-US" smtClean="0"/>
+              <a:t>4/22/26</a:t>
             </a:fld>
             <a:endParaRPr lang="en-US"/>
           </a:p>
@@ -8267,6 +7957,7 @@
           <a:p>
             <a:fld id="{258ECF37-3CC2-C74D-A5F5-BBEAD8F9A4D4}" type="slidenum">
               <a:rPr lang="en-US" smtClean="0"/>
+              <a:t>‹#›</a:t>
             </a:fld>
             <a:endParaRPr lang="en-US"/>
           </a:p>
@@ -8321,7 +8012,6 @@
               <a:rPr lang="en-US"/>
               <a:t>Click to edit Master title style</a:t>
             </a:r>
-            <a:endParaRPr lang="en-US"/>
           </a:p>
         </p:txBody>
       </p:sp>
@@ -8350,7 +8040,6 @@
               <a:rPr lang="en-US"/>
               <a:t>Click to edit Master text styles</a:t>
             </a:r>
-            <a:endParaRPr lang="en-US"/>
           </a:p>
           <a:p>
             <a:pPr lvl="1"/>
@@ -8358,7 +8047,6 @@
               <a:rPr lang="en-US"/>
               <a:t>Second level</a:t>
             </a:r>
-            <a:endParaRPr lang="en-US"/>
           </a:p>
           <a:p>
             <a:pPr lvl="2"/>
@@ -8366,7 +8054,6 @@
               <a:rPr lang="en-US"/>
               <a:t>Third level</a:t>
             </a:r>
-            <a:endParaRPr lang="en-US"/>
           </a:p>
           <a:p>
             <a:pPr lvl="3"/>
@@ -8374,7 +8061,6 @@
               <a:rPr lang="en-US"/>
               <a:t>Fourth level</a:t>
             </a:r>
-            <a:endParaRPr lang="en-US"/>
           </a:p>
           <a:p>
             <a:pPr lvl="4"/>
@@ -8382,7 +8068,6 @@
               <a:rPr lang="en-US"/>
               <a:t>Fifth level</a:t>
             </a:r>
-            <a:endParaRPr lang="en-US"/>
           </a:p>
         </p:txBody>
       </p:sp>
@@ -8403,6 +8088,7 @@
           <a:p>
             <a:fld id="{0897BCBE-A2DD-2248-8676-657FEEB74689}" type="datetimeFigureOut">
               <a:rPr lang="en-US" smtClean="0"/>
+              <a:t>4/22/26</a:t>
             </a:fld>
             <a:endParaRPr lang="en-US"/>
           </a:p>
@@ -8444,6 +8130,7 @@
           <a:p>
             <a:fld id="{258ECF37-3CC2-C74D-A5F5-BBEAD8F9A4D4}" type="slidenum">
               <a:rPr lang="en-US" smtClean="0"/>
+              <a:t>‹#›</a:t>
             </a:fld>
             <a:endParaRPr lang="en-US"/>
           </a:p>
@@ -8493,7 +8180,6 @@
               <a:rPr lang="en-US"/>
               <a:t>Click to edit Master title style</a:t>
             </a:r>
-            <a:endParaRPr lang="en-US"/>
           </a:p>
         </p:txBody>
       </p:sp>
@@ -8517,7 +8203,6 @@
               <a:rPr lang="en-US"/>
               <a:t>Click to edit Master text styles</a:t>
             </a:r>
-            <a:endParaRPr lang="en-US"/>
           </a:p>
           <a:p>
             <a:pPr lvl="1"/>
@@ -8525,7 +8210,6 @@
               <a:rPr lang="en-US"/>
               <a:t>Second level</a:t>
             </a:r>
-            <a:endParaRPr lang="en-US"/>
           </a:p>
           <a:p>
             <a:pPr lvl="2"/>
@@ -8533,7 +8217,6 @@
               <a:rPr lang="en-US"/>
               <a:t>Third level</a:t>
             </a:r>
-            <a:endParaRPr lang="en-US"/>
           </a:p>
           <a:p>
             <a:pPr lvl="3"/>
@@ -8541,7 +8224,6 @@
               <a:rPr lang="en-US"/>
               <a:t>Fourth level</a:t>
             </a:r>
-            <a:endParaRPr lang="en-US"/>
           </a:p>
           <a:p>
             <a:pPr lvl="4"/>
@@ -8549,7 +8231,6 @@
               <a:rPr lang="en-US"/>
               <a:t>Fifth level</a:t>
             </a:r>
-            <a:endParaRPr lang="en-US"/>
           </a:p>
         </p:txBody>
       </p:sp>
@@ -8570,6 +8251,7 @@
           <a:p>
             <a:fld id="{0897BCBE-A2DD-2248-8676-657FEEB74689}" type="datetimeFigureOut">
               <a:rPr lang="en-US" smtClean="0"/>
+              <a:t>4/22/26</a:t>
             </a:fld>
             <a:endParaRPr lang="en-US"/>
           </a:p>
@@ -8611,6 +8293,7 @@
           <a:p>
             <a:fld id="{258ECF37-3CC2-C74D-A5F5-BBEAD8F9A4D4}" type="slidenum">
               <a:rPr lang="en-US" smtClean="0"/>
+              <a:t>‹#›</a:t>
             </a:fld>
             <a:endParaRPr lang="en-US"/>
           </a:p>
@@ -8669,7 +8352,6 @@
               <a:rPr lang="en-US"/>
               <a:t>Click to edit Master title style</a:t>
             </a:r>
-            <a:endParaRPr lang="en-US"/>
           </a:p>
         </p:txBody>
       </p:sp>
@@ -8789,7 +8471,6 @@
               <a:rPr lang="en-US"/>
               <a:t>Click to edit Master text styles</a:t>
             </a:r>
-            <a:endParaRPr lang="en-US"/>
           </a:p>
         </p:txBody>
       </p:sp>
@@ -8810,6 +8491,7 @@
           <a:p>
             <a:fld id="{0897BCBE-A2DD-2248-8676-657FEEB74689}" type="datetimeFigureOut">
               <a:rPr lang="en-US" smtClean="0"/>
+              <a:t>4/22/26</a:t>
             </a:fld>
             <a:endParaRPr lang="en-US"/>
           </a:p>
@@ -8851,6 +8533,7 @@
           <a:p>
             <a:fld id="{258ECF37-3CC2-C74D-A5F5-BBEAD8F9A4D4}" type="slidenum">
               <a:rPr lang="en-US" smtClean="0"/>
+              <a:t>‹#›</a:t>
             </a:fld>
             <a:endParaRPr lang="en-US"/>
           </a:p>
@@ -8900,7 +8583,6 @@
               <a:rPr lang="en-US"/>
               <a:t>Click to edit Master title style</a:t>
             </a:r>
-            <a:endParaRPr lang="en-US"/>
           </a:p>
         </p:txBody>
       </p:sp>
@@ -8957,7 +8639,6 @@
               <a:rPr lang="en-US"/>
               <a:t>Click to edit Master text styles</a:t>
             </a:r>
-            <a:endParaRPr lang="en-US"/>
           </a:p>
           <a:p>
             <a:pPr lvl="1"/>
@@ -8965,7 +8646,6 @@
               <a:rPr lang="en-US"/>
               <a:t>Second level</a:t>
             </a:r>
-            <a:endParaRPr lang="en-US"/>
           </a:p>
           <a:p>
             <a:pPr lvl="2"/>
@@ -8973,7 +8653,6 @@
               <a:rPr lang="en-US"/>
               <a:t>Third level</a:t>
             </a:r>
-            <a:endParaRPr lang="en-US"/>
           </a:p>
           <a:p>
             <a:pPr lvl="3"/>
@@ -8981,7 +8660,6 @@
               <a:rPr lang="en-US"/>
               <a:t>Fourth level</a:t>
             </a:r>
-            <a:endParaRPr lang="en-US"/>
           </a:p>
           <a:p>
             <a:pPr lvl="4"/>
@@ -8989,7 +8667,6 @@
               <a:rPr lang="en-US"/>
               <a:t>Fifth level</a:t>
             </a:r>
-            <a:endParaRPr lang="en-US"/>
           </a:p>
         </p:txBody>
       </p:sp>
@@ -9046,7 +8723,6 @@
               <a:rPr lang="en-US"/>
               <a:t>Click to edit Master text styles</a:t>
             </a:r>
-            <a:endParaRPr lang="en-US"/>
           </a:p>
           <a:p>
             <a:pPr lvl="1"/>
@@ -9054,7 +8730,6 @@
               <a:rPr lang="en-US"/>
               <a:t>Second level</a:t>
             </a:r>
-            <a:endParaRPr lang="en-US"/>
           </a:p>
           <a:p>
             <a:pPr lvl="2"/>
@@ -9062,7 +8737,6 @@
               <a:rPr lang="en-US"/>
               <a:t>Third level</a:t>
             </a:r>
-            <a:endParaRPr lang="en-US"/>
           </a:p>
           <a:p>
             <a:pPr lvl="3"/>
@@ -9070,7 +8744,6 @@
               <a:rPr lang="en-US"/>
               <a:t>Fourth level</a:t>
             </a:r>
-            <a:endParaRPr lang="en-US"/>
           </a:p>
           <a:p>
             <a:pPr lvl="4"/>
@@ -9078,7 +8751,6 @@
               <a:rPr lang="en-US"/>
               <a:t>Fifth level</a:t>
             </a:r>
-            <a:endParaRPr lang="en-US"/>
           </a:p>
         </p:txBody>
       </p:sp>
@@ -9099,6 +8771,7 @@
           <a:p>
             <a:fld id="{0897BCBE-A2DD-2248-8676-657FEEB74689}" type="datetimeFigureOut">
               <a:rPr lang="en-US" smtClean="0"/>
+              <a:t>4/22/26</a:t>
             </a:fld>
             <a:endParaRPr lang="en-US"/>
           </a:p>
@@ -9140,6 +8813,7 @@
           <a:p>
             <a:fld id="{258ECF37-3CC2-C74D-A5F5-BBEAD8F9A4D4}" type="slidenum">
               <a:rPr lang="en-US" smtClean="0"/>
+              <a:t>‹#›</a:t>
             </a:fld>
             <a:endParaRPr lang="en-US"/>
           </a:p>
@@ -9193,7 +8867,6 @@
               <a:rPr lang="en-US"/>
               <a:t>Click to edit Master title style</a:t>
             </a:r>
-            <a:endParaRPr lang="en-US"/>
           </a:p>
         </p:txBody>
       </p:sp>
@@ -9259,7 +8932,6 @@
               <a:rPr lang="en-US"/>
               <a:t>Click to edit Master text styles</a:t>
             </a:r>
-            <a:endParaRPr lang="en-US"/>
           </a:p>
         </p:txBody>
       </p:sp>
@@ -9316,7 +8988,6 @@
               <a:rPr lang="en-US"/>
               <a:t>Click to edit Master text styles</a:t>
             </a:r>
-            <a:endParaRPr lang="en-US"/>
           </a:p>
           <a:p>
             <a:pPr lvl="1"/>
@@ -9324,7 +8995,6 @@
               <a:rPr lang="en-US"/>
               <a:t>Second level</a:t>
             </a:r>
-            <a:endParaRPr lang="en-US"/>
           </a:p>
           <a:p>
             <a:pPr lvl="2"/>
@@ -9332,7 +9002,6 @@
               <a:rPr lang="en-US"/>
               <a:t>Third level</a:t>
             </a:r>
-            <a:endParaRPr lang="en-US"/>
           </a:p>
           <a:p>
             <a:pPr lvl="3"/>
@@ -9340,7 +9009,6 @@
               <a:rPr lang="en-US"/>
               <a:t>Fourth level</a:t>
             </a:r>
-            <a:endParaRPr lang="en-US"/>
           </a:p>
           <a:p>
             <a:pPr lvl="4"/>
@@ -9348,7 +9016,6 @@
               <a:rPr lang="en-US"/>
               <a:t>Fifth level</a:t>
             </a:r>
-            <a:endParaRPr lang="en-US"/>
           </a:p>
         </p:txBody>
       </p:sp>
@@ -9414,7 +9081,6 @@
               <a:rPr lang="en-US"/>
               <a:t>Click to edit Master text styles</a:t>
             </a:r>
-            <a:endParaRPr lang="en-US"/>
           </a:p>
         </p:txBody>
       </p:sp>
@@ -9471,7 +9137,6 @@
               <a:rPr lang="en-US"/>
               <a:t>Click to edit Master text styles</a:t>
             </a:r>
-            <a:endParaRPr lang="en-US"/>
           </a:p>
           <a:p>
             <a:pPr lvl="1"/>
@@ -9479,7 +9144,6 @@
               <a:rPr lang="en-US"/>
               <a:t>Second level</a:t>
             </a:r>
-            <a:endParaRPr lang="en-US"/>
           </a:p>
           <a:p>
             <a:pPr lvl="2"/>
@@ -9487,7 +9151,6 @@
               <a:rPr lang="en-US"/>
               <a:t>Third level</a:t>
             </a:r>
-            <a:endParaRPr lang="en-US"/>
           </a:p>
           <a:p>
             <a:pPr lvl="3"/>
@@ -9495,7 +9158,6 @@
               <a:rPr lang="en-US"/>
               <a:t>Fourth level</a:t>
             </a:r>
-            <a:endParaRPr lang="en-US"/>
           </a:p>
           <a:p>
             <a:pPr lvl="4"/>
@@ -9503,7 +9165,6 @@
               <a:rPr lang="en-US"/>
               <a:t>Fifth level</a:t>
             </a:r>
-            <a:endParaRPr lang="en-US"/>
           </a:p>
         </p:txBody>
       </p:sp>
@@ -9524,6 +9185,7 @@
           <a:p>
             <a:fld id="{0897BCBE-A2DD-2248-8676-657FEEB74689}" type="datetimeFigureOut">
               <a:rPr lang="en-US" smtClean="0"/>
+              <a:t>4/22/26</a:t>
             </a:fld>
             <a:endParaRPr lang="en-US"/>
           </a:p>
@@ -9565,6 +9227,7 @@
           <a:p>
             <a:fld id="{258ECF37-3CC2-C74D-A5F5-BBEAD8F9A4D4}" type="slidenum">
               <a:rPr lang="en-US" smtClean="0"/>
+              <a:t>‹#›</a:t>
             </a:fld>
             <a:endParaRPr lang="en-US"/>
           </a:p>
@@ -9614,7 +9277,6 @@
               <a:rPr lang="en-US"/>
               <a:t>Click to edit Master title style</a:t>
             </a:r>
-            <a:endParaRPr lang="en-US"/>
           </a:p>
         </p:txBody>
       </p:sp>
@@ -9635,6 +9297,7 @@
           <a:p>
             <a:fld id="{0897BCBE-A2DD-2248-8676-657FEEB74689}" type="datetimeFigureOut">
               <a:rPr lang="en-US" smtClean="0"/>
+              <a:t>4/22/26</a:t>
             </a:fld>
             <a:endParaRPr lang="en-US"/>
           </a:p>
@@ -9676,6 +9339,7 @@
           <a:p>
             <a:fld id="{258ECF37-3CC2-C74D-A5F5-BBEAD8F9A4D4}" type="slidenum">
               <a:rPr lang="en-US" smtClean="0"/>
+              <a:t>‹#›</a:t>
             </a:fld>
             <a:endParaRPr lang="en-US"/>
           </a:p>
@@ -9723,6 +9387,7 @@
           <a:p>
             <a:fld id="{0897BCBE-A2DD-2248-8676-657FEEB74689}" type="datetimeFigureOut">
               <a:rPr lang="en-US" smtClean="0"/>
+              <a:t>4/22/26</a:t>
             </a:fld>
             <a:endParaRPr lang="en-US"/>
           </a:p>
@@ -9764,6 +9429,7 @@
           <a:p>
             <a:fld id="{258ECF37-3CC2-C74D-A5F5-BBEAD8F9A4D4}" type="slidenum">
               <a:rPr lang="en-US" smtClean="0"/>
+              <a:t>‹#›</a:t>
             </a:fld>
             <a:endParaRPr lang="en-US"/>
           </a:p>
@@ -9822,7 +9488,6 @@
               <a:rPr lang="en-US"/>
               <a:t>Click to edit Master title style</a:t>
             </a:r>
-            <a:endParaRPr lang="en-US"/>
           </a:p>
         </p:txBody>
       </p:sp>
@@ -9879,7 +9544,6 @@
               <a:rPr lang="en-US"/>
               <a:t>Click to edit Master text styles</a:t>
             </a:r>
-            <a:endParaRPr lang="en-US"/>
           </a:p>
           <a:p>
             <a:pPr lvl="1"/>
@@ -9887,7 +9551,6 @@
               <a:rPr lang="en-US"/>
               <a:t>Second level</a:t>
             </a:r>
-            <a:endParaRPr lang="en-US"/>
           </a:p>
           <a:p>
             <a:pPr lvl="2"/>
@@ -9895,7 +9558,6 @@
               <a:rPr lang="en-US"/>
               <a:t>Third level</a:t>
             </a:r>
-            <a:endParaRPr lang="en-US"/>
           </a:p>
           <a:p>
             <a:pPr lvl="3"/>
@@ -9903,7 +9565,6 @@
               <a:rPr lang="en-US"/>
               <a:t>Fourth level</a:t>
             </a:r>
-            <a:endParaRPr lang="en-US"/>
           </a:p>
           <a:p>
             <a:pPr lvl="4"/>
@@ -9911,7 +9572,6 @@
               <a:rPr lang="en-US"/>
               <a:t>Fifth level</a:t>
             </a:r>
-            <a:endParaRPr lang="en-US"/>
           </a:p>
         </p:txBody>
       </p:sp>
@@ -9977,7 +9637,6 @@
               <a:rPr lang="en-US"/>
               <a:t>Click to edit Master text styles</a:t>
             </a:r>
-            <a:endParaRPr lang="en-US"/>
           </a:p>
         </p:txBody>
       </p:sp>
@@ -9998,6 +9657,7 @@
           <a:p>
             <a:fld id="{0897BCBE-A2DD-2248-8676-657FEEB74689}" type="datetimeFigureOut">
               <a:rPr lang="en-US" smtClean="0"/>
+              <a:t>4/22/26</a:t>
             </a:fld>
             <a:endParaRPr lang="en-US"/>
           </a:p>
@@ -10039,6 +9699,7 @@
           <a:p>
             <a:fld id="{258ECF37-3CC2-C74D-A5F5-BBEAD8F9A4D4}" type="slidenum">
               <a:rPr lang="en-US" smtClean="0"/>
+              <a:t>‹#›</a:t>
             </a:fld>
             <a:endParaRPr lang="en-US"/>
           </a:p>
@@ -10097,7 +9758,6 @@
               <a:rPr lang="en-US"/>
               <a:t>Click to edit Master title style</a:t>
             </a:r>
-            <a:endParaRPr lang="en-US"/>
           </a:p>
         </p:txBody>
       </p:sp>
@@ -10224,7 +9884,6 @@
               <a:rPr lang="en-US"/>
               <a:t>Click to edit Master text styles</a:t>
             </a:r>
-            <a:endParaRPr lang="en-US"/>
           </a:p>
         </p:txBody>
       </p:sp>
@@ -10245,6 +9904,7 @@
           <a:p>
             <a:fld id="{0897BCBE-A2DD-2248-8676-657FEEB74689}" type="datetimeFigureOut">
               <a:rPr lang="en-US" smtClean="0"/>
+              <a:t>4/22/26</a:t>
             </a:fld>
             <a:endParaRPr lang="en-US"/>
           </a:p>
@@ -10286,6 +9946,7 @@
           <a:p>
             <a:fld id="{258ECF37-3CC2-C74D-A5F5-BBEAD8F9A4D4}" type="slidenum">
               <a:rPr lang="en-US" smtClean="0"/>
+              <a:t>‹#›</a:t>
             </a:fld>
             <a:endParaRPr lang="en-US"/>
           </a:p>
@@ -10350,7 +10011,6 @@
               <a:rPr lang="en-US"/>
               <a:t>Click to edit Master title style</a:t>
             </a:r>
-            <a:endParaRPr lang="en-US"/>
           </a:p>
         </p:txBody>
       </p:sp>
@@ -10384,7 +10044,6 @@
               <a:rPr lang="en-US"/>
               <a:t>Click to edit Master text styles</a:t>
             </a:r>
-            <a:endParaRPr lang="en-US"/>
           </a:p>
           <a:p>
             <a:pPr lvl="1"/>
@@ -10392,7 +10051,6 @@
               <a:rPr lang="en-US"/>
               <a:t>Second level</a:t>
             </a:r>
-            <a:endParaRPr lang="en-US"/>
           </a:p>
           <a:p>
             <a:pPr lvl="2"/>
@@ -10400,7 +10058,6 @@
               <a:rPr lang="en-US"/>
               <a:t>Third level</a:t>
             </a:r>
-            <a:endParaRPr lang="en-US"/>
           </a:p>
           <a:p>
             <a:pPr lvl="3"/>
@@ -10408,7 +10065,6 @@
               <a:rPr lang="en-US"/>
               <a:t>Fourth level</a:t>
             </a:r>
-            <a:endParaRPr lang="en-US"/>
           </a:p>
           <a:p>
             <a:pPr lvl="4"/>
@@ -10416,7 +10072,6 @@
               <a:rPr lang="en-US"/>
               <a:t>Fifth level</a:t>
             </a:r>
-            <a:endParaRPr lang="en-US"/>
           </a:p>
         </p:txBody>
       </p:sp>
@@ -10455,6 +10110,7 @@
           <a:p>
             <a:fld id="{0897BCBE-A2DD-2248-8676-657FEEB74689}" type="datetimeFigureOut">
               <a:rPr lang="en-US" smtClean="0"/>
+              <a:t>4/22/26</a:t>
             </a:fld>
             <a:endParaRPr lang="en-US"/>
           </a:p>
@@ -10532,6 +10188,7 @@
           <a:p>
             <a:fld id="{258ECF37-3CC2-C74D-A5F5-BBEAD8F9A4D4}" type="slidenum">
               <a:rPr lang="en-US" smtClean="0"/>
+              <a:t>‹#›</a:t>
             </a:fld>
             <a:endParaRPr lang="en-US"/>
           </a:p>
@@ -10840,7 +10497,7 @@
           <p:nvPr/>
         </p:nvPicPr>
         <p:blipFill rotWithShape="1">
-          <a:blip r:embed="rId1"/>
+          <a:blip r:embed="rId2"/>
           <a:srcRect l="11000" r="-1" b="-1"/>
           <a:stretch>
             <a:fillRect/>
@@ -11256,7 +10913,7 @@
           <p:nvPr/>
         </p:nvPicPr>
         <p:blipFill>
-          <a:blip r:embed="rId1"/>
+          <a:blip r:embed="rId2"/>
           <a:stretch>
             <a:fillRect/>
           </a:stretch>
@@ -11610,7 +11267,7 @@
         </p:xfrm>
         <a:graphic>
           <a:graphicData uri="http://schemas.openxmlformats.org/drawingml/2006/diagram">
-            <dgm:relIds xmlns:dgm="http://schemas.openxmlformats.org/drawingml/2006/diagram" xmlns:r="http://schemas.openxmlformats.org/officeDocument/2006/relationships" r:dm="rId1" r:lo="rId2" r:qs="rId3" r:cs="rId4"/>
+            <dgm:relIds xmlns:dgm="http://schemas.openxmlformats.org/drawingml/2006/diagram" xmlns:r="http://schemas.openxmlformats.org/officeDocument/2006/relationships" r:dm="rId2" r:lo="rId3" r:qs="rId4" r:cs="rId5"/>
           </a:graphicData>
         </a:graphic>
       </p:graphicFrame>
@@ -11841,11 +11498,6 @@
               </a:rPr>
               <a:t>项目部署</a:t>
             </a:r>
-            <a:endParaRPr kumimoji="1" lang="zh-CN" altLang="en-US">
-              <a:solidFill>
-                <a:srgbClr val="FFFFFF"/>
-              </a:solidFill>
-            </a:endParaRPr>
           </a:p>
         </p:txBody>
       </p:sp>
@@ -12086,7 +11738,6 @@
               <a:rPr lang="en-US" dirty="0"/>
               <a:t>复习指南</a:t>
             </a:r>
-            <a:endParaRPr lang="en-US" dirty="0"/>
           </a:p>
         </p:txBody>
       </p:sp>
@@ -12103,7 +11754,7 @@
         <p:spPr/>
         <p:txBody>
           <a:bodyPr>
-            <a:normAutofit fontScale="92500" lnSpcReduction="20000"/>
+            <a:normAutofit fontScale="85000" lnSpcReduction="10000"/>
           </a:bodyPr>
           <a:lstStyle/>
           <a:p>
@@ -12121,7 +11772,7 @@
             </a:r>
             <a:r>
               <a:rPr lang="en-US" altLang="zh-CN" dirty="0"/>
-              <a:t>(20*2</a:t>
+              <a:t>(10*2</a:t>
             </a:r>
             <a:r>
               <a:rPr lang="en-US" altLang="zh-CN" dirty="0">
@@ -12133,17 +11784,16 @@
               <a:rPr lang="en-US" altLang="zh-CN" dirty="0"/>
               <a:t>)</a:t>
             </a:r>
-            <a:endParaRPr lang="en-US" altLang="zh-CN" dirty="0"/>
           </a:p>
           <a:p>
             <a:pPr lvl="1"/>
             <a:r>
-              <a:rPr lang="zh-CN" altLang="en-US" dirty="0"/>
+              <a:rPr lang="zh-CN" altLang="en-US"/>
               <a:t>简答题</a:t>
             </a:r>
             <a:r>
-              <a:rPr lang="en-US" altLang="zh-CN" dirty="0"/>
-              <a:t>( 5*4</a:t>
+              <a:rPr lang="en-US" altLang="zh-CN"/>
+              <a:t>(8*5</a:t>
             </a:r>
             <a:r>
               <a:rPr lang="en-US" altLang="zh-CN" dirty="0">
@@ -12155,7 +11805,6 @@
               <a:rPr lang="en-US" altLang="zh-CN" dirty="0"/>
               <a:t>)</a:t>
             </a:r>
-            <a:endParaRPr lang="en-US" altLang="zh-CN" dirty="0"/>
           </a:p>
           <a:p>
             <a:pPr lvl="1"/>
@@ -12165,9 +11814,8 @@
             </a:r>
             <a:r>
               <a:rPr lang="en-US" altLang="zh-CN" dirty="0"/>
-              <a:t>( 5*2’)</a:t>
-            </a:r>
-            <a:endParaRPr lang="en-US" altLang="zh-CN" dirty="0"/>
+              <a:t>(10*2’)</a:t>
+            </a:r>
           </a:p>
           <a:p>
             <a:pPr lvl="1"/>
@@ -12177,19 +11825,8 @@
             </a:r>
             <a:r>
               <a:rPr lang="en-US" altLang="zh-CN" dirty="0"/>
-              <a:t>(20</a:t>
-            </a:r>
-            <a:r>
-              <a:rPr lang="en-US" altLang="zh-CN" dirty="0">
-                <a:sym typeface="+mn-ea"/>
-              </a:rPr>
-              <a:t>’</a:t>
-            </a:r>
-            <a:r>
-              <a:rPr lang="en-US" altLang="zh-CN" dirty="0"/>
-              <a:t>+10’)</a:t>
-            </a:r>
-            <a:endParaRPr lang="en-US" altLang="zh-CN" dirty="0"/>
+              <a:t>(10’)</a:t>
+            </a:r>
           </a:p>
           <a:p>
             <a:pPr lvl="1"/>
@@ -12247,7 +11884,11 @@
             </a:r>
             <a:r>
               <a:rPr lang="en-US" altLang="zh-CN" dirty="0"/>
-              <a:t>Servlet</a:t>
+              <a:t> </a:t>
+            </a:r>
+            <a:r>
+              <a:rPr lang="en-US" altLang="zh-CN" dirty="0" err="1"/>
+              <a:t>JSP+JavaBean</a:t>
             </a:r>
             <a:r>
               <a:rPr lang="zh-CN" altLang="en-US" dirty="0"/>
@@ -12259,7 +11900,7 @@
             </a:r>
             <a:r>
               <a:rPr lang="zh-CN" altLang="en-US" dirty="0"/>
-              <a:t>，实验课内容，</a:t>
+              <a:t>，</a:t>
             </a:r>
             <a:r>
               <a:rPr lang="en-US" altLang="zh-CN" dirty="0"/>
@@ -12283,7 +11924,15 @@
             </a:r>
             <a:r>
               <a:rPr lang="zh-CN" altLang="en-US" dirty="0"/>
-              <a:t>的基础知识。</a:t>
+              <a:t>的基础知识，</a:t>
+            </a:r>
+            <a:r>
+              <a:rPr lang="en-US" altLang="zh-CN" dirty="0"/>
+              <a:t> Servlet</a:t>
+            </a:r>
+            <a:r>
+              <a:rPr lang="zh-CN" altLang="en-US" dirty="0"/>
+              <a:t>是核心</a:t>
             </a:r>
             <a:endParaRPr lang="en-US" altLang="zh-CN" dirty="0"/>
           </a:p>
@@ -12318,20 +11967,12 @@
               <a:t>JQuery</a:t>
             </a:r>
             <a:r>
-              <a:rPr lang="zh-CN" altLang="en-US" dirty="0" err="1"/>
+              <a:rPr lang="zh-CN" altLang="en-US" dirty="0"/>
               <a:t>、</a:t>
             </a:r>
             <a:r>
               <a:rPr lang="en-US" altLang="zh-CN" dirty="0"/>
               <a:t>Vue</a:t>
-            </a:r>
-            <a:r>
-              <a:rPr lang="zh-CN" altLang="en-US" dirty="0"/>
-              <a:t>、</a:t>
-            </a:r>
-            <a:r>
-              <a:rPr lang="en-US" altLang="zh-CN" dirty="0"/>
-              <a:t>JSP</a:t>
             </a:r>
             <a:r>
               <a:rPr lang="zh-CN" altLang="en-US" dirty="0"/>
@@ -12363,7 +12004,23 @@
             </a:r>
             <a:r>
               <a:rPr lang="zh-CN" altLang="en-US" dirty="0"/>
-              <a:t>：考试之前把实验内容做完</a:t>
+              <a:t>：考试之前把实验内容做完；用</a:t>
+            </a:r>
+            <a:r>
+              <a:rPr lang="en-US" altLang="zh-CN" dirty="0"/>
+              <a:t>Servlet</a:t>
+            </a:r>
+            <a:r>
+              <a:rPr lang="zh-CN" altLang="en-US" dirty="0"/>
+              <a:t>写一个传统的</a:t>
+            </a:r>
+            <a:r>
+              <a:rPr lang="en-US" altLang="zh-CN" dirty="0"/>
+              <a:t>web</a:t>
+            </a:r>
+            <a:r>
+              <a:rPr lang="zh-CN" altLang="en-US" dirty="0"/>
+              <a:t>响应页面。</a:t>
             </a:r>
             <a:endParaRPr lang="en-US" altLang="zh-CN" dirty="0"/>
           </a:p>
@@ -12411,7 +12068,7 @@
           <p:nvPr/>
         </p:nvPicPr>
         <p:blipFill rotWithShape="1">
-          <a:blip r:embed="rId1">
+          <a:blip r:embed="rId3">
             <a:duotone>
               <a:schemeClr val="bg2">
                 <a:shade val="45000"/>
@@ -12547,7 +12204,7 @@
         </p:xfrm>
         <a:graphic>
           <a:graphicData uri="http://schemas.openxmlformats.org/drawingml/2006/diagram">
-            <dgm:relIds xmlns:dgm="http://schemas.openxmlformats.org/drawingml/2006/diagram" xmlns:r="http://schemas.openxmlformats.org/officeDocument/2006/relationships" r:dm="rId2" r:lo="rId3" r:qs="rId4" r:cs="rId5"/>
+            <dgm:relIds xmlns:dgm="http://schemas.openxmlformats.org/drawingml/2006/diagram" xmlns:r="http://schemas.openxmlformats.org/officeDocument/2006/relationships" r:dm="rId4" r:lo="rId5" r:qs="rId6" r:cs="rId7"/>
           </a:graphicData>
         </a:graphic>
       </p:graphicFrame>
@@ -12607,7 +12264,6 @@
               <a:rPr kumimoji="1" lang="zh-CN" altLang="en-US" dirty="0"/>
               <a:t>默认单例</a:t>
             </a:r>
-            <a:endParaRPr kumimoji="1" lang="zh-CN" altLang="en-US" dirty="0"/>
           </a:p>
         </p:txBody>
       </p:sp>
@@ -12620,7 +12276,7 @@
           <p:nvPr/>
         </p:nvPicPr>
         <p:blipFill>
-          <a:blip r:embed="rId1"/>
+          <a:blip r:embed="rId2"/>
           <a:stretch>
             <a:fillRect/>
           </a:stretch>
@@ -12730,7 +12386,6 @@
               <a:rPr kumimoji="1" lang="zh-CN" altLang="en-US" dirty="0"/>
               <a:t>这种代码</a:t>
             </a:r>
-            <a:endParaRPr kumimoji="1" lang="zh-CN" altLang="en-US" dirty="0"/>
           </a:p>
         </p:txBody>
       </p:sp>
@@ -12745,7 +12400,7 @@
           </p:nvPr>
         </p:nvPicPr>
         <p:blipFill>
-          <a:blip r:embed="rId1"/>
+          <a:blip r:embed="rId2"/>
           <a:stretch>
             <a:fillRect/>
           </a:stretch>
@@ -12990,7 +12645,7 @@
           <p:nvPr/>
         </p:nvPicPr>
         <p:blipFill>
-          <a:blip r:embed="rId1"/>
+          <a:blip r:embed="rId3"/>
           <a:stretch>
             <a:fillRect/>
           </a:stretch>
@@ -13076,7 +12731,6 @@
               <a:rPr lang="en-US" dirty="0"/>
               <a:t>初始化阶段</a:t>
             </a:r>
-            <a:endParaRPr lang="en-US" dirty="0"/>
           </a:p>
         </p:txBody>
       </p:sp>
@@ -13089,7 +12743,7 @@
           <p:nvPr/>
         </p:nvPicPr>
         <p:blipFill>
-          <a:blip r:embed="rId1"/>
+          <a:blip r:embed="rId2"/>
           <a:stretch>
             <a:fillRect/>
           </a:stretch>
@@ -13167,7 +12821,6 @@
               <a:rPr lang="en-US" dirty="0"/>
               <a:t>匹配阶段</a:t>
             </a:r>
-            <a:endParaRPr lang="en-US" dirty="0"/>
           </a:p>
         </p:txBody>
       </p:sp>
@@ -13180,7 +12833,7 @@
           <p:nvPr/>
         </p:nvPicPr>
         <p:blipFill>
-          <a:blip r:embed="rId1"/>
+          <a:blip r:embed="rId2"/>
           <a:stretch>
             <a:fillRect/>
           </a:stretch>
@@ -13267,7 +12920,7 @@
           <p:nvPr/>
         </p:nvPicPr>
         <p:blipFill>
-          <a:blip r:embed="rId1"/>
+          <a:blip r:embed="rId2"/>
           <a:stretch>
             <a:fillRect/>
           </a:stretch>
@@ -13345,7 +12998,6 @@
               <a:rPr lang="en-US" dirty="0"/>
               <a:t>执行阶段</a:t>
             </a:r>
-            <a:endParaRPr lang="en-US" dirty="0"/>
           </a:p>
         </p:txBody>
       </p:sp>
@@ -13358,7 +13010,7 @@
           <p:nvPr/>
         </p:nvPicPr>
         <p:blipFill>
-          <a:blip r:embed="rId1"/>
+          <a:blip r:embed="rId2"/>
           <a:stretch>
             <a:fillRect/>
           </a:stretch>
@@ -13697,6 +13349,7 @@
       </a:style>
     </a:lnDef>
   </a:objectDefaults>
+  <a:extraClrSchemeLst/>
   <a:extLst>
     <a:ext uri="{05A4C25C-085E-4340-85A3-A5531E510DB2}">
       <thm15:themeFamily xmlns:thm15="http://schemas.microsoft.com/office/thememl/2012/main" name="Office Theme" id="{62F939B6-93AF-4DB8-9C6B-D6C7DFDC589F}" vid="{4A3C46E8-61CC-4603-A589-7422A47A8E4A}"/>
@@ -13956,6 +13609,8 @@
       </a:bgFillStyleLst>
     </a:fmtScheme>
   </a:themeElements>
+  <a:objectDefaults/>
+  <a:extraClrSchemeLst/>
   <a:extLst>
     <a:ext uri="{05A4C25C-085E-4340-85A3-A5531E510DB2}">
       <thm15:themeFamily xmlns:thm15="http://schemas.microsoft.com/office/thememl/2012/main" name="Office Theme" id="{62F939B6-93AF-4DB8-9C6B-D6C7DFDC589F}" vid="{4A3C46E8-61CC-4603-A589-7422A47A8E4A}"/>

</xml_diff>